<commit_message>
Update July'26 presentation with RKAM vs NKAM accountability structure
Add organizational clarity:
- Slide 6: RKAM (Zone-wise) vs NKAM (Chain-wise) Action Matrix
  * RKAM: North, South-1, South-2, West, Central (5 regional zones)
  * NKAM: Apollo, Reliance Retail, D-Mart, Walmart, Metro C&C (5 national chains)

- Slide 7: Success Metrics & Ownership Table
  * Aug target: ₹260 Cr (+7.7% vs Jul ₹241.4 Cr)
  * Zone-level targets (RKAM accountability)
  * Chain-level targets (NKAM accountability)
  * Individual review dates for each entity

Ownership clarity:
- RKAM: Regional distribution, zone penetration, store network expansion
- NKAM: National account relationship, chain-wide visibility, SKU placement
- Weekly tracking: Mon 9am Ops Sync

Co-Authored-By: Claude Haiku 4.5 <noreply@anthropic.com>
Claude-Session: https://claude.ai/code/session_01NVFPVKhn4kRYk1yEujsL2r
</commit_message>
<xml_diff>
--- a/July_26_MT_Executive_Review.pptx
+++ b/July_26_MT_Executive_Review.pptx
@@ -10,6 +10,8 @@
     <p:sldId id="258" r:id="rId9"/>
     <p:sldId id="259" r:id="rId10"/>
     <p:sldId id="260" r:id="rId11"/>
+    <p:sldId id="261" r:id="rId12"/>
+    <p:sldId id="262" r:id="rId13"/>
   </p:sldIdLst>
   <p:sldSz cx="9144000" cy="6858000" type="screen4x3"/>
   <p:notesSz cx="6858000" cy="9144000"/>
@@ -7181,6 +7183,4676 @@
             </a:pPr>
             <a:r>
               <a:t>MP + CG slowest tier. Opportunity gap: only 1.2% of 8-metro Face Wash NSV. Action: Q4 pilot—2 Indore chains, hero-SKU bundling to build baseline.</a:t>
+            </a:r>
+          </a:p>
+        </p:txBody>
+      </p:sp>
+    </p:spTree>
+  </p:cSld>
+  <p:clrMapOvr>
+    <a:masterClrMapping/>
+  </p:clrMapOvr>
+</p:sld>
+</file>
+
+<file path=ppt/slides/slide6.xml><?xml version="1.0" encoding="utf-8"?>
+<p:sld xmlns:a="http://schemas.openxmlformats.org/drawingml/2006/main" xmlns:p="http://schemas.openxmlformats.org/presentationml/2006/main" xmlns:r="http://schemas.openxmlformats.org/officeDocument/2006/relationships">
+  <p:cSld>
+    <p:bg>
+      <p:bgPr>
+        <a:solidFill>
+          <a:srgbClr val="FFFFFF"/>
+        </a:solidFill>
+        <a:effectLst/>
+      </p:bgPr>
+    </p:bg>
+    <p:spTree>
+      <p:nvGrpSpPr>
+        <p:cNvPr id="1" name=""/>
+        <p:cNvGrpSpPr/>
+        <p:nvPr/>
+      </p:nvGrpSpPr>
+      <p:grpSpPr/>
+      <p:sp>
+        <p:nvSpPr>
+          <p:cNvPr id="2" name="Rectangle 1"/>
+          <p:cNvSpPr/>
+          <p:nvPr/>
+        </p:nvSpPr>
+        <p:spPr>
+          <a:xfrm>
+            <a:off x="0" y="0"/>
+            <a:ext cx="9144000" cy="731520"/>
+          </a:xfrm>
+          <a:prstGeom prst="rect">
+            <a:avLst/>
+          </a:prstGeom>
+          <a:solidFill>
+            <a:srgbClr val="0D1B2A"/>
+          </a:solidFill>
+          <a:ln/>
+        </p:spPr>
+        <p:style>
+          <a:lnRef idx="1">
+            <a:schemeClr val="accent1"/>
+          </a:lnRef>
+          <a:fillRef idx="3">
+            <a:schemeClr val="accent1"/>
+          </a:fillRef>
+          <a:effectRef idx="2">
+            <a:schemeClr val="accent1"/>
+          </a:effectRef>
+          <a:fontRef idx="minor">
+            <a:schemeClr val="lt1"/>
+          </a:fontRef>
+        </p:style>
+        <p:txBody>
+          <a:bodyPr rtlCol="0" anchor="ctr"/>
+          <a:lstStyle/>
+          <a:p>
+            <a:pPr algn="ctr"/>
+          </a:p>
+        </p:txBody>
+      </p:sp>
+      <p:sp>
+        <p:nvSpPr>
+          <p:cNvPr id="3" name="TextBox 2"/>
+          <p:cNvSpPr txBox="1"/>
+          <p:nvPr/>
+        </p:nvSpPr>
+        <p:spPr>
+          <a:xfrm>
+            <a:off x="457200" y="137160"/>
+            <a:ext cx="8229600" cy="548640"/>
+          </a:xfrm>
+          <a:prstGeom prst="rect">
+            <a:avLst/>
+          </a:prstGeom>
+          <a:noFill/>
+        </p:spPr>
+        <p:txBody>
+          <a:bodyPr wrap="none">
+            <a:spAutoFit/>
+          </a:bodyPr>
+          <a:lstStyle/>
+          <a:p>
+            <a:pPr>
+              <a:defRPr sz="2400" b="1">
+                <a:solidFill>
+                  <a:srgbClr val="FFFFFF"/>
+                </a:solidFill>
+              </a:defRPr>
+            </a:pPr>
+            <a:r>
+              <a:t>Execution Roadmap: RKAM (Zone) vs NKAM (Chain) Accountability</a:t>
+            </a:r>
+          </a:p>
+        </p:txBody>
+      </p:sp>
+      <p:sp>
+        <p:nvSpPr>
+          <p:cNvPr id="4" name="Rectangle 3"/>
+          <p:cNvSpPr/>
+          <p:nvPr/>
+        </p:nvSpPr>
+        <p:spPr>
+          <a:xfrm>
+            <a:off x="457200" y="914400"/>
+            <a:ext cx="3931920" cy="320040"/>
+          </a:xfrm>
+          <a:prstGeom prst="rect">
+            <a:avLst/>
+          </a:prstGeom>
+          <a:solidFill>
+            <a:srgbClr val="7B2CBA"/>
+          </a:solidFill>
+          <a:ln/>
+        </p:spPr>
+        <p:style>
+          <a:lnRef idx="1">
+            <a:schemeClr val="accent1"/>
+          </a:lnRef>
+          <a:fillRef idx="3">
+            <a:schemeClr val="accent1"/>
+          </a:fillRef>
+          <a:effectRef idx="2">
+            <a:schemeClr val="accent1"/>
+          </a:effectRef>
+          <a:fontRef idx="minor">
+            <a:schemeClr val="lt1"/>
+          </a:fontRef>
+        </p:style>
+        <p:txBody>
+          <a:bodyPr rtlCol="0" anchor="ctr"/>
+          <a:lstStyle/>
+          <a:p>
+            <a:pPr algn="ctr">
+              <a:defRPr b="1" sz="1200">
+                <a:solidFill>
+                  <a:srgbClr val="FFFFFF"/>
+                </a:solidFill>
+              </a:defRPr>
+            </a:pPr>
+            <a:r>
+              <a:t>RKAM — Regional Key Account Manager (Zone-wise)</a:t>
+            </a:r>
+          </a:p>
+        </p:txBody>
+      </p:sp>
+      <p:sp>
+        <p:nvSpPr>
+          <p:cNvPr id="5" name="Rectangle 4"/>
+          <p:cNvSpPr/>
+          <p:nvPr/>
+        </p:nvSpPr>
+        <p:spPr>
+          <a:xfrm>
+            <a:off x="4480560" y="914400"/>
+            <a:ext cx="4206240" cy="320040"/>
+          </a:xfrm>
+          <a:prstGeom prst="rect">
+            <a:avLst/>
+          </a:prstGeom>
+          <a:solidFill>
+            <a:srgbClr val="006EE6"/>
+          </a:solidFill>
+          <a:ln/>
+        </p:spPr>
+        <p:style>
+          <a:lnRef idx="1">
+            <a:schemeClr val="accent1"/>
+          </a:lnRef>
+          <a:fillRef idx="3">
+            <a:schemeClr val="accent1"/>
+          </a:fillRef>
+          <a:effectRef idx="2">
+            <a:schemeClr val="accent1"/>
+          </a:effectRef>
+          <a:fontRef idx="minor">
+            <a:schemeClr val="lt1"/>
+          </a:fontRef>
+        </p:style>
+        <p:txBody>
+          <a:bodyPr rtlCol="0" anchor="ctr"/>
+          <a:lstStyle/>
+          <a:p>
+            <a:pPr algn="ctr">
+              <a:defRPr b="1" sz="1200">
+                <a:solidFill>
+                  <a:srgbClr val="FFFFFF"/>
+                </a:solidFill>
+              </a:defRPr>
+            </a:pPr>
+            <a:r>
+              <a:t>NKAM — National Key Account Manager (Chain-wise)</a:t>
+            </a:r>
+          </a:p>
+        </p:txBody>
+      </p:sp>
+      <p:sp>
+        <p:nvSpPr>
+          <p:cNvPr id="6" name="Rectangle 5"/>
+          <p:cNvSpPr/>
+          <p:nvPr/>
+        </p:nvSpPr>
+        <p:spPr>
+          <a:xfrm>
+            <a:off x="457200" y="1371600"/>
+            <a:ext cx="3931920" cy="228600"/>
+          </a:xfrm>
+          <a:prstGeom prst="rect">
+            <a:avLst/>
+          </a:prstGeom>
+          <a:solidFill>
+            <a:srgbClr val="F5F5F5"/>
+          </a:solidFill>
+          <a:ln w="19050">
+            <a:solidFill>
+              <a:srgbClr val="7B2CBA"/>
+            </a:solidFill>
+          </a:ln>
+        </p:spPr>
+        <p:style>
+          <a:lnRef idx="1">
+            <a:schemeClr val="accent1"/>
+          </a:lnRef>
+          <a:fillRef idx="3">
+            <a:schemeClr val="accent1"/>
+          </a:fillRef>
+          <a:effectRef idx="2">
+            <a:schemeClr val="accent1"/>
+          </a:effectRef>
+          <a:fontRef idx="minor">
+            <a:schemeClr val="lt1"/>
+          </a:fontRef>
+        </p:style>
+        <p:txBody>
+          <a:bodyPr rtlCol="0" anchor="ctr"/>
+          <a:lstStyle/>
+          <a:p>
+            <a:pPr algn="ctr">
+              <a:defRPr b="1" sz="1000">
+                <a:solidFill>
+                  <a:srgbClr val="7B2CBA"/>
+                </a:solidFill>
+              </a:defRPr>
+            </a:pPr>
+            <a:r>
+              <a:t>NORTH (₹68.2 Cr, +12.4%)</a:t>
+            </a:r>
+          </a:p>
+        </p:txBody>
+      </p:sp>
+      <p:sp>
+        <p:nvSpPr>
+          <p:cNvPr id="7" name="TextBox 6"/>
+          <p:cNvSpPr txBox="1"/>
+          <p:nvPr/>
+        </p:nvSpPr>
+        <p:spPr>
+          <a:xfrm>
+            <a:off x="548640" y="1505029248000"/>
+            <a:ext cx="3749039" cy="548640"/>
+          </a:xfrm>
+          <a:prstGeom prst="rect">
+            <a:avLst/>
+          </a:prstGeom>
+          <a:noFill/>
+        </p:spPr>
+        <p:txBody>
+          <a:bodyPr wrap="square">
+            <a:spAutoFit/>
+          </a:bodyPr>
+          <a:lstStyle/>
+          <a:p>
+            <a:pPr>
+              <a:spcBef>
+                <a:spcPts val="200"/>
+              </a:spcBef>
+              <a:spcAft>
+                <a:spcPts val="200"/>
+              </a:spcAft>
+              <a:defRPr sz="850">
+                <a:solidFill>
+                  <a:srgbClr val="0D1B2A"/>
+                </a:solidFill>
+              </a:defRPr>
+            </a:pPr>
+            <a:r>
+              <a:t>• Scale Himalaya 5-store network +15%</a:t>
+            </a:r>
+            <a:br/>
+            <a:r>
+              <a:t>• Expand Garnier distribution +12%</a:t>
+            </a:r>
+            <a:br/>
+            <a:r>
+              <a:t>• Owner: North RKAM | Deadline: 12-Aug</a:t>
+            </a:r>
+          </a:p>
+        </p:txBody>
+      </p:sp>
+      <p:sp>
+        <p:nvSpPr>
+          <p:cNvPr id="8" name="Rectangle 7"/>
+          <p:cNvSpPr/>
+          <p:nvPr/>
+        </p:nvSpPr>
+        <p:spPr>
+          <a:xfrm>
+            <a:off x="457200" y="2240280"/>
+            <a:ext cx="3931920" cy="228600"/>
+          </a:xfrm>
+          <a:prstGeom prst="rect">
+            <a:avLst/>
+          </a:prstGeom>
+          <a:solidFill>
+            <a:srgbClr val="F5F5F5"/>
+          </a:solidFill>
+          <a:ln w="19050">
+            <a:solidFill>
+              <a:srgbClr val="7B2CBA"/>
+            </a:solidFill>
+          </a:ln>
+        </p:spPr>
+        <p:style>
+          <a:lnRef idx="1">
+            <a:schemeClr val="accent1"/>
+          </a:lnRef>
+          <a:fillRef idx="3">
+            <a:schemeClr val="accent1"/>
+          </a:fillRef>
+          <a:effectRef idx="2">
+            <a:schemeClr val="accent1"/>
+          </a:effectRef>
+          <a:fontRef idx="minor">
+            <a:schemeClr val="lt1"/>
+          </a:fontRef>
+        </p:style>
+        <p:txBody>
+          <a:bodyPr rtlCol="0" anchor="ctr"/>
+          <a:lstStyle/>
+          <a:p>
+            <a:pPr algn="ctr">
+              <a:defRPr b="1" sz="1000">
+                <a:solidFill>
+                  <a:srgbClr val="7B2CBA"/>
+                </a:solidFill>
+              </a:defRPr>
+            </a:pPr>
+            <a:r>
+              <a:t>SOUTH-1 (₹71.3 Cr, +16.2%)</a:t>
+            </a:r>
+          </a:p>
+        </p:txBody>
+      </p:sp>
+      <p:sp>
+        <p:nvSpPr>
+          <p:cNvPr id="9" name="TextBox 8"/>
+          <p:cNvSpPr txBox="1"/>
+          <p:nvPr/>
+        </p:nvSpPr>
+        <p:spPr>
+          <a:xfrm>
+            <a:off x="548640" y="2299350240000"/>
+            <a:ext cx="3749039" cy="548640"/>
+          </a:xfrm>
+          <a:prstGeom prst="rect">
+            <a:avLst/>
+          </a:prstGeom>
+          <a:noFill/>
+        </p:spPr>
+        <p:txBody>
+          <a:bodyPr wrap="square">
+            <a:spAutoFit/>
+          </a:bodyPr>
+          <a:lstStyle/>
+          <a:p>
+            <a:pPr>
+              <a:spcBef>
+                <a:spcPts val="200"/>
+              </a:spcBef>
+              <a:spcAft>
+                <a:spcPts val="200"/>
+              </a:spcAft>
+              <a:defRPr sz="850">
+                <a:solidFill>
+                  <a:srgbClr val="0D1B2A"/>
+                </a:solidFill>
+              </a:defRPr>
+            </a:pPr>
+            <a:r>
+              <a:t>• Launch Himalaya 3-SKU combo (12 chains)</a:t>
+            </a:r>
+            <a:br/>
+            <a:r>
+              <a:t>• Chennai expansion +18% by Aug-31</a:t>
+            </a:r>
+            <a:br/>
+            <a:r>
+              <a:t>• Owner: South-1 RKAM | Deadline: 15-Aug</a:t>
+            </a:r>
+          </a:p>
+        </p:txBody>
+      </p:sp>
+      <p:sp>
+        <p:nvSpPr>
+          <p:cNvPr id="10" name="Rectangle 9"/>
+          <p:cNvSpPr/>
+          <p:nvPr/>
+        </p:nvSpPr>
+        <p:spPr>
+          <a:xfrm>
+            <a:off x="457200" y="3108960"/>
+            <a:ext cx="3931920" cy="228600"/>
+          </a:xfrm>
+          <a:prstGeom prst="rect">
+            <a:avLst/>
+          </a:prstGeom>
+          <a:solidFill>
+            <a:srgbClr val="F5F5F5"/>
+          </a:solidFill>
+          <a:ln w="19050">
+            <a:solidFill>
+              <a:srgbClr val="7B2CBA"/>
+            </a:solidFill>
+          </a:ln>
+        </p:spPr>
+        <p:style>
+          <a:lnRef idx="1">
+            <a:schemeClr val="accent1"/>
+          </a:lnRef>
+          <a:fillRef idx="3">
+            <a:schemeClr val="accent1"/>
+          </a:fillRef>
+          <a:effectRef idx="2">
+            <a:schemeClr val="accent1"/>
+          </a:effectRef>
+          <a:fontRef idx="minor">
+            <a:schemeClr val="lt1"/>
+          </a:fontRef>
+        </p:style>
+        <p:txBody>
+          <a:bodyPr rtlCol="0" anchor="ctr"/>
+          <a:lstStyle/>
+          <a:p>
+            <a:pPr algn="ctr">
+              <a:defRPr b="1" sz="1000">
+                <a:solidFill>
+                  <a:srgbClr val="7B2CBA"/>
+                </a:solidFill>
+              </a:defRPr>
+            </a:pPr>
+            <a:r>
+              <a:t>SOUTH-2 (₹42.1 Cr, +8.3%)</a:t>
+            </a:r>
+          </a:p>
+        </p:txBody>
+      </p:sp>
+      <p:sp>
+        <p:nvSpPr>
+          <p:cNvPr id="11" name="TextBox 10"/>
+          <p:cNvSpPr txBox="1"/>
+          <p:nvPr/>
+        </p:nvSpPr>
+        <p:spPr>
+          <a:xfrm>
+            <a:off x="548640" y="3093671232000"/>
+            <a:ext cx="3749039" cy="548640"/>
+          </a:xfrm>
+          <a:prstGeom prst="rect">
+            <a:avLst/>
+          </a:prstGeom>
+          <a:noFill/>
+        </p:spPr>
+        <p:txBody>
+          <a:bodyPr wrap="square">
+            <a:spAutoFit/>
+          </a:bodyPr>
+          <a:lstStyle/>
+          <a:p>
+            <a:pPr>
+              <a:spcBef>
+                <a:spcPts val="200"/>
+              </a:spcBef>
+              <a:spcAft>
+                <a:spcPts val="200"/>
+              </a:spcAft>
+              <a:defRPr sz="850">
+                <a:solidFill>
+                  <a:srgbClr val="0D1B2A"/>
+                </a:solidFill>
+              </a:defRPr>
+            </a:pPr>
+            <a:r>
+              <a:t>• Run Reliance-exclusive promo Q3</a:t>
+            </a:r>
+            <a:br/>
+            <a:r>
+              <a:t>• Stabilize Hyderabad chain network</a:t>
+            </a:r>
+            <a:br/>
+            <a:r>
+              <a:t>• Owner: South-2 RKAM | Deadline: 20-Aug</a:t>
+            </a:r>
+          </a:p>
+        </p:txBody>
+      </p:sp>
+      <p:sp>
+        <p:nvSpPr>
+          <p:cNvPr id="12" name="Rectangle 11"/>
+          <p:cNvSpPr/>
+          <p:nvPr/>
+        </p:nvSpPr>
+        <p:spPr>
+          <a:xfrm>
+            <a:off x="457200" y="3977639"/>
+            <a:ext cx="3931920" cy="228600"/>
+          </a:xfrm>
+          <a:prstGeom prst="rect">
+            <a:avLst/>
+          </a:prstGeom>
+          <a:solidFill>
+            <a:srgbClr val="F5F5F5"/>
+          </a:solidFill>
+          <a:ln w="19050">
+            <a:solidFill>
+              <a:srgbClr val="7B2CBA"/>
+            </a:solidFill>
+          </a:ln>
+        </p:spPr>
+        <p:style>
+          <a:lnRef idx="1">
+            <a:schemeClr val="accent1"/>
+          </a:lnRef>
+          <a:fillRef idx="3">
+            <a:schemeClr val="accent1"/>
+          </a:fillRef>
+          <a:effectRef idx="2">
+            <a:schemeClr val="accent1"/>
+          </a:effectRef>
+          <a:fontRef idx="minor">
+            <a:schemeClr val="lt1"/>
+          </a:fontRef>
+        </p:style>
+        <p:txBody>
+          <a:bodyPr rtlCol="0" anchor="ctr"/>
+          <a:lstStyle/>
+          <a:p>
+            <a:pPr algn="ctr">
+              <a:defRPr b="1" sz="1000">
+                <a:solidFill>
+                  <a:srgbClr val="7B2CBA"/>
+                </a:solidFill>
+              </a:defRPr>
+            </a:pPr>
+            <a:r>
+              <a:t>WEST (₹48.7 Cr, +10.1%)</a:t>
+            </a:r>
+          </a:p>
+        </p:txBody>
+      </p:sp>
+      <p:sp>
+        <p:nvSpPr>
+          <p:cNvPr id="13" name="TextBox 12"/>
+          <p:cNvSpPr txBox="1"/>
+          <p:nvPr/>
+        </p:nvSpPr>
+        <p:spPr>
+          <a:xfrm>
+            <a:off x="548640" y="3887991309600"/>
+            <a:ext cx="3749039" cy="548640"/>
+          </a:xfrm>
+          <a:prstGeom prst="rect">
+            <a:avLst/>
+          </a:prstGeom>
+          <a:noFill/>
+        </p:spPr>
+        <p:txBody>
+          <a:bodyPr wrap="square">
+            <a:spAutoFit/>
+          </a:bodyPr>
+          <a:lstStyle/>
+          <a:p>
+            <a:pPr>
+              <a:spcBef>
+                <a:spcPts val="200"/>
+              </a:spcBef>
+              <a:spcAft>
+                <a:spcPts val="200"/>
+              </a:spcAft>
+              <a:defRPr sz="850">
+                <a:solidFill>
+                  <a:srgbClr val="0D1B2A"/>
+                </a:solidFill>
+              </a:defRPr>
+            </a:pPr>
+            <a:r>
+              <a:t>• Mumbai consolidation +40 stores</a:t>
+            </a:r>
+            <a:br/>
+            <a:r>
+              <a:t>• Gujarat Garnier hero-SKU push</a:t>
+            </a:r>
+            <a:br/>
+            <a:r>
+              <a:t>• Owner: West RKAM | Deadline: 18-Aug</a:t>
+            </a:r>
+          </a:p>
+        </p:txBody>
+      </p:sp>
+      <p:sp>
+        <p:nvSpPr>
+          <p:cNvPr id="14" name="Rectangle 13"/>
+          <p:cNvSpPr/>
+          <p:nvPr/>
+        </p:nvSpPr>
+        <p:spPr>
+          <a:xfrm>
+            <a:off x="457200" y="4846320"/>
+            <a:ext cx="3931920" cy="228600"/>
+          </a:xfrm>
+          <a:prstGeom prst="rect">
+            <a:avLst/>
+          </a:prstGeom>
+          <a:solidFill>
+            <a:srgbClr val="F5F5F5"/>
+          </a:solidFill>
+          <a:ln w="19050">
+            <a:solidFill>
+              <a:srgbClr val="7B2CBA"/>
+            </a:solidFill>
+          </a:ln>
+        </p:spPr>
+        <p:style>
+          <a:lnRef idx="1">
+            <a:schemeClr val="accent1"/>
+          </a:lnRef>
+          <a:fillRef idx="3">
+            <a:schemeClr val="accent1"/>
+          </a:fillRef>
+          <a:effectRef idx="2">
+            <a:schemeClr val="accent1"/>
+          </a:effectRef>
+          <a:fontRef idx="minor">
+            <a:schemeClr val="lt1"/>
+          </a:fontRef>
+        </p:style>
+        <p:txBody>
+          <a:bodyPr rtlCol="0" anchor="ctr"/>
+          <a:lstStyle/>
+          <a:p>
+            <a:pPr algn="ctr">
+              <a:defRPr b="1" sz="1000">
+                <a:solidFill>
+                  <a:srgbClr val="7B2CBA"/>
+                </a:solidFill>
+              </a:defRPr>
+            </a:pPr>
+            <a:r>
+              <a:t>CENTRAL (₹6.1 Cr, +5.7%)</a:t>
+            </a:r>
+          </a:p>
+        </p:txBody>
+      </p:sp>
+      <p:sp>
+        <p:nvSpPr>
+          <p:cNvPr id="15" name="TextBox 14"/>
+          <p:cNvSpPr txBox="1"/>
+          <p:nvPr/>
+        </p:nvSpPr>
+        <p:spPr>
+          <a:xfrm>
+            <a:off x="548640" y="4682313216000"/>
+            <a:ext cx="3749039" cy="548640"/>
+          </a:xfrm>
+          <a:prstGeom prst="rect">
+            <a:avLst/>
+          </a:prstGeom>
+          <a:noFill/>
+        </p:spPr>
+        <p:txBody>
+          <a:bodyPr wrap="square">
+            <a:spAutoFit/>
+          </a:bodyPr>
+          <a:lstStyle/>
+          <a:p>
+            <a:pPr>
+              <a:spcBef>
+                <a:spcPts val="200"/>
+              </a:spcBef>
+              <a:spcAft>
+                <a:spcPts val="200"/>
+              </a:spcAft>
+              <a:defRPr sz="850">
+                <a:solidFill>
+                  <a:srgbClr val="0D1B2A"/>
+                </a:solidFill>
+              </a:defRPr>
+            </a:pPr>
+            <a:r>
+              <a:t>• Q4 pilot: Indore 2-chain baseline</a:t>
+            </a:r>
+            <a:br/>
+            <a:r>
+              <a:t>• SKU bundling test (₹0.2 Cr initial)</a:t>
+            </a:r>
+            <a:br/>
+            <a:r>
+              <a:t>• Owner: Central RKAM | Deadline: 25-Aug</a:t>
+            </a:r>
+          </a:p>
+        </p:txBody>
+      </p:sp>
+      <p:sp>
+        <p:nvSpPr>
+          <p:cNvPr id="16" name="Rectangle 15"/>
+          <p:cNvSpPr/>
+          <p:nvPr/>
+        </p:nvSpPr>
+        <p:spPr>
+          <a:xfrm>
+            <a:off x="4480560" y="1371600"/>
+            <a:ext cx="4206240" cy="228600"/>
+          </a:xfrm>
+          <a:prstGeom prst="rect">
+            <a:avLst/>
+          </a:prstGeom>
+          <a:solidFill>
+            <a:srgbClr val="F5F5F5"/>
+          </a:solidFill>
+          <a:ln w="19050">
+            <a:solidFill>
+              <a:srgbClr val="006EE6"/>
+            </a:solidFill>
+          </a:ln>
+        </p:spPr>
+        <p:style>
+          <a:lnRef idx="1">
+            <a:schemeClr val="accent1"/>
+          </a:lnRef>
+          <a:fillRef idx="3">
+            <a:schemeClr val="accent1"/>
+          </a:fillRef>
+          <a:effectRef idx="2">
+            <a:schemeClr val="accent1"/>
+          </a:effectRef>
+          <a:fontRef idx="minor">
+            <a:schemeClr val="lt1"/>
+          </a:fontRef>
+        </p:style>
+        <p:txBody>
+          <a:bodyPr rtlCol="0" anchor="ctr"/>
+          <a:lstStyle/>
+          <a:p>
+            <a:pPr algn="ctr">
+              <a:defRPr b="1" sz="1000">
+                <a:solidFill>
+                  <a:srgbClr val="006EE6"/>
+                </a:solidFill>
+              </a:defRPr>
+            </a:pPr>
+            <a:r>
+              <a:t>APOLLO</a:t>
+            </a:r>
+          </a:p>
+        </p:txBody>
+      </p:sp>
+      <p:sp>
+        <p:nvSpPr>
+          <p:cNvPr id="17" name="TextBox 16"/>
+          <p:cNvSpPr txBox="1"/>
+          <p:nvPr/>
+        </p:nvSpPr>
+        <p:spPr>
+          <a:xfrm>
+            <a:off x="4572000" y="1505029248000"/>
+            <a:ext cx="4023360" cy="548640"/>
+          </a:xfrm>
+          <a:prstGeom prst="rect">
+            <a:avLst/>
+          </a:prstGeom>
+          <a:noFill/>
+        </p:spPr>
+        <p:txBody>
+          <a:bodyPr wrap="square">
+            <a:spAutoFit/>
+          </a:bodyPr>
+          <a:lstStyle/>
+          <a:p>
+            <a:pPr>
+              <a:spcBef>
+                <a:spcPts val="200"/>
+              </a:spcBef>
+              <a:spcAft>
+                <a:spcPts val="200"/>
+              </a:spcAft>
+              <a:defRPr sz="850">
+                <a:solidFill>
+                  <a:srgbClr val="0D1B2A"/>
+                </a:solidFill>
+              </a:defRPr>
+            </a:pPr>
+            <a:r>
+              <a:t>• Face Wash hero-SKU placement: 95% store coverage</a:t>
+            </a:r>
+            <a:br/>
+            <a:r>
+              <a:t>• Himalaya premium range: 18% growth target</a:t>
+            </a:r>
+            <a:br/>
+            <a:r>
+              <a:t>• Owner: Apollo NKAM | Target: ₹32.4 Cr (+12%)</a:t>
+            </a:r>
+          </a:p>
+        </p:txBody>
+      </p:sp>
+      <p:sp>
+        <p:nvSpPr>
+          <p:cNvPr id="18" name="Rectangle 17"/>
+          <p:cNvSpPr/>
+          <p:nvPr/>
+        </p:nvSpPr>
+        <p:spPr>
+          <a:xfrm>
+            <a:off x="4480560" y="2240280"/>
+            <a:ext cx="4206240" cy="228600"/>
+          </a:xfrm>
+          <a:prstGeom prst="rect">
+            <a:avLst/>
+          </a:prstGeom>
+          <a:solidFill>
+            <a:srgbClr val="F5F5F5"/>
+          </a:solidFill>
+          <a:ln w="19050">
+            <a:solidFill>
+              <a:srgbClr val="006EE6"/>
+            </a:solidFill>
+          </a:ln>
+        </p:spPr>
+        <p:style>
+          <a:lnRef idx="1">
+            <a:schemeClr val="accent1"/>
+          </a:lnRef>
+          <a:fillRef idx="3">
+            <a:schemeClr val="accent1"/>
+          </a:fillRef>
+          <a:effectRef idx="2">
+            <a:schemeClr val="accent1"/>
+          </a:effectRef>
+          <a:fontRef idx="minor">
+            <a:schemeClr val="lt1"/>
+          </a:fontRef>
+        </p:style>
+        <p:txBody>
+          <a:bodyPr rtlCol="0" anchor="ctr"/>
+          <a:lstStyle/>
+          <a:p>
+            <a:pPr algn="ctr">
+              <a:defRPr b="1" sz="1000">
+                <a:solidFill>
+                  <a:srgbClr val="006EE6"/>
+                </a:solidFill>
+              </a:defRPr>
+            </a:pPr>
+            <a:r>
+              <a:t>RELIANCE RETAIL</a:t>
+            </a:r>
+          </a:p>
+        </p:txBody>
+      </p:sp>
+      <p:sp>
+        <p:nvSpPr>
+          <p:cNvPr id="19" name="TextBox 18"/>
+          <p:cNvSpPr txBox="1"/>
+          <p:nvPr/>
+        </p:nvSpPr>
+        <p:spPr>
+          <a:xfrm>
+            <a:off x="4572000" y="2299350240000"/>
+            <a:ext cx="4023360" cy="548640"/>
+          </a:xfrm>
+          <a:prstGeom prst="rect">
+            <a:avLst/>
+          </a:prstGeom>
+          <a:noFill/>
+        </p:spPr>
+        <p:txBody>
+          <a:bodyPr wrap="square">
+            <a:spAutoFit/>
+          </a:bodyPr>
+          <a:lstStyle/>
+          <a:p>
+            <a:pPr>
+              <a:spcBef>
+                <a:spcPts val="200"/>
+              </a:spcBef>
+              <a:spcAft>
+                <a:spcPts val="200"/>
+              </a:spcAft>
+              <a:defRPr sz="850">
+                <a:solidFill>
+                  <a:srgbClr val="0D1B2A"/>
+                </a:solidFill>
+              </a:defRPr>
+            </a:pPr>
+            <a:r>
+              <a:t>• Exclusive facewash bundle promotion</a:t>
+            </a:r>
+            <a:br/>
+            <a:r>
+              <a:t>• Clean &amp; Clear + Himalaya combo tier</a:t>
+            </a:r>
+            <a:br/>
+            <a:r>
+              <a:t>• Owner: Reliance NKAM | Target: ₹28.1 Cr (+15%)</a:t>
+            </a:r>
+          </a:p>
+        </p:txBody>
+      </p:sp>
+      <p:sp>
+        <p:nvSpPr>
+          <p:cNvPr id="20" name="Rectangle 19"/>
+          <p:cNvSpPr/>
+          <p:nvPr/>
+        </p:nvSpPr>
+        <p:spPr>
+          <a:xfrm>
+            <a:off x="4480560" y="3108960"/>
+            <a:ext cx="4206240" cy="228600"/>
+          </a:xfrm>
+          <a:prstGeom prst="rect">
+            <a:avLst/>
+          </a:prstGeom>
+          <a:solidFill>
+            <a:srgbClr val="F5F5F5"/>
+          </a:solidFill>
+          <a:ln w="19050">
+            <a:solidFill>
+              <a:srgbClr val="006EE6"/>
+            </a:solidFill>
+          </a:ln>
+        </p:spPr>
+        <p:style>
+          <a:lnRef idx="1">
+            <a:schemeClr val="accent1"/>
+          </a:lnRef>
+          <a:fillRef idx="3">
+            <a:schemeClr val="accent1"/>
+          </a:fillRef>
+          <a:effectRef idx="2">
+            <a:schemeClr val="accent1"/>
+          </a:effectRef>
+          <a:fontRef idx="minor">
+            <a:schemeClr val="lt1"/>
+          </a:fontRef>
+        </p:style>
+        <p:txBody>
+          <a:bodyPr rtlCol="0" anchor="ctr"/>
+          <a:lstStyle/>
+          <a:p>
+            <a:pPr algn="ctr">
+              <a:defRPr b="1" sz="1000">
+                <a:solidFill>
+                  <a:srgbClr val="006EE6"/>
+                </a:solidFill>
+              </a:defRPr>
+            </a:pPr>
+            <a:r>
+              <a:t>D-MART</a:t>
+            </a:r>
+          </a:p>
+        </p:txBody>
+      </p:sp>
+      <p:sp>
+        <p:nvSpPr>
+          <p:cNvPr id="21" name="TextBox 20"/>
+          <p:cNvSpPr txBox="1"/>
+          <p:nvPr/>
+        </p:nvSpPr>
+        <p:spPr>
+          <a:xfrm>
+            <a:off x="4572000" y="3093671232000"/>
+            <a:ext cx="4023360" cy="548640"/>
+          </a:xfrm>
+          <a:prstGeom prst="rect">
+            <a:avLst/>
+          </a:prstGeom>
+          <a:noFill/>
+        </p:spPr>
+        <p:txBody>
+          <a:bodyPr wrap="square">
+            <a:spAutoFit/>
+          </a:bodyPr>
+          <a:lstStyle/>
+          <a:p>
+            <a:pPr>
+              <a:spcBef>
+                <a:spcPts val="200"/>
+              </a:spcBef>
+              <a:spcAft>
+                <a:spcPts val="200"/>
+              </a:spcAft>
+              <a:defRPr sz="850">
+                <a:solidFill>
+                  <a:srgbClr val="0D1B2A"/>
+                </a:solidFill>
+              </a:defRPr>
+            </a:pPr>
+            <a:r>
+              <a:t>• Volume push on budget-tier facewash</a:t>
+            </a:r>
+            <a:br/>
+            <a:r>
+              <a:t>• Garnier Powder positioning (premium tier)</a:t>
+            </a:r>
+            <a:br/>
+            <a:r>
+              <a:t>• Owner: D-Mart NKAM | Target: ₹24.3 Cr (+18%)</a:t>
+            </a:r>
+          </a:p>
+        </p:txBody>
+      </p:sp>
+      <p:sp>
+        <p:nvSpPr>
+          <p:cNvPr id="22" name="Rectangle 21"/>
+          <p:cNvSpPr/>
+          <p:nvPr/>
+        </p:nvSpPr>
+        <p:spPr>
+          <a:xfrm>
+            <a:off x="4480560" y="3977639"/>
+            <a:ext cx="4206240" cy="228600"/>
+          </a:xfrm>
+          <a:prstGeom prst="rect">
+            <a:avLst/>
+          </a:prstGeom>
+          <a:solidFill>
+            <a:srgbClr val="F5F5F5"/>
+          </a:solidFill>
+          <a:ln w="19050">
+            <a:solidFill>
+              <a:srgbClr val="006EE6"/>
+            </a:solidFill>
+          </a:ln>
+        </p:spPr>
+        <p:style>
+          <a:lnRef idx="1">
+            <a:schemeClr val="accent1"/>
+          </a:lnRef>
+          <a:fillRef idx="3">
+            <a:schemeClr val="accent1"/>
+          </a:fillRef>
+          <a:effectRef idx="2">
+            <a:schemeClr val="accent1"/>
+          </a:effectRef>
+          <a:fontRef idx="minor">
+            <a:schemeClr val="lt1"/>
+          </a:fontRef>
+        </p:style>
+        <p:txBody>
+          <a:bodyPr rtlCol="0" anchor="ctr"/>
+          <a:lstStyle/>
+          <a:p>
+            <a:pPr algn="ctr">
+              <a:defRPr b="1" sz="1000">
+                <a:solidFill>
+                  <a:srgbClr val="006EE6"/>
+                </a:solidFill>
+              </a:defRPr>
+            </a:pPr>
+            <a:r>
+              <a:t>WALMART</a:t>
+            </a:r>
+          </a:p>
+        </p:txBody>
+      </p:sp>
+      <p:sp>
+        <p:nvSpPr>
+          <p:cNvPr id="23" name="TextBox 22"/>
+          <p:cNvSpPr txBox="1"/>
+          <p:nvPr/>
+        </p:nvSpPr>
+        <p:spPr>
+          <a:xfrm>
+            <a:off x="4572000" y="3887991309600"/>
+            <a:ext cx="4023360" cy="548640"/>
+          </a:xfrm>
+          <a:prstGeom prst="rect">
+            <a:avLst/>
+          </a:prstGeom>
+          <a:noFill/>
+        </p:spPr>
+        <p:txBody>
+          <a:bodyPr wrap="square">
+            <a:spAutoFit/>
+          </a:bodyPr>
+          <a:lstStyle/>
+          <a:p>
+            <a:pPr>
+              <a:spcBef>
+                <a:spcPts val="200"/>
+              </a:spcBef>
+              <a:spcAft>
+                <a:spcPts val="200"/>
+              </a:spcAft>
+              <a:defRPr sz="850">
+                <a:solidFill>
+                  <a:srgbClr val="0D1B2A"/>
+                </a:solidFill>
+              </a:defRPr>
+            </a:pPr>
+            <a:r>
+              <a:t>• Himalaya Day/Night Cream expansion</a:t>
+            </a:r>
+            <a:br/>
+            <a:r>
+              <a:t>• 5-metro store adds (15 new doors)</a:t>
+            </a:r>
+            <a:br/>
+            <a:r>
+              <a:t>• Owner: Walmart NKAM | Target: ₹12.1 Cr (+14%)</a:t>
+            </a:r>
+          </a:p>
+        </p:txBody>
+      </p:sp>
+      <p:sp>
+        <p:nvSpPr>
+          <p:cNvPr id="24" name="Rectangle 23"/>
+          <p:cNvSpPr/>
+          <p:nvPr/>
+        </p:nvSpPr>
+        <p:spPr>
+          <a:xfrm>
+            <a:off x="4480560" y="4846320"/>
+            <a:ext cx="4206240" cy="228600"/>
+          </a:xfrm>
+          <a:prstGeom prst="rect">
+            <a:avLst/>
+          </a:prstGeom>
+          <a:solidFill>
+            <a:srgbClr val="F5F5F5"/>
+          </a:solidFill>
+          <a:ln w="19050">
+            <a:solidFill>
+              <a:srgbClr val="006EE6"/>
+            </a:solidFill>
+          </a:ln>
+        </p:spPr>
+        <p:style>
+          <a:lnRef idx="1">
+            <a:schemeClr val="accent1"/>
+          </a:lnRef>
+          <a:fillRef idx="3">
+            <a:schemeClr val="accent1"/>
+          </a:fillRef>
+          <a:effectRef idx="2">
+            <a:schemeClr val="accent1"/>
+          </a:effectRef>
+          <a:fontRef idx="minor">
+            <a:schemeClr val="lt1"/>
+          </a:fontRef>
+        </p:style>
+        <p:txBody>
+          <a:bodyPr rtlCol="0" anchor="ctr"/>
+          <a:lstStyle/>
+          <a:p>
+            <a:pPr algn="ctr">
+              <a:defRPr b="1" sz="1000">
+                <a:solidFill>
+                  <a:srgbClr val="006EE6"/>
+                </a:solidFill>
+              </a:defRPr>
+            </a:pPr>
+            <a:r>
+              <a:t>METRO C&amp;C</a:t>
+            </a:r>
+          </a:p>
+        </p:txBody>
+      </p:sp>
+      <p:sp>
+        <p:nvSpPr>
+          <p:cNvPr id="25" name="TextBox 24"/>
+          <p:cNvSpPr txBox="1"/>
+          <p:nvPr/>
+        </p:nvSpPr>
+        <p:spPr>
+          <a:xfrm>
+            <a:off x="4572000" y="4682313216000"/>
+            <a:ext cx="4023360" cy="548640"/>
+          </a:xfrm>
+          <a:prstGeom prst="rect">
+            <a:avLst/>
+          </a:prstGeom>
+          <a:noFill/>
+        </p:spPr>
+        <p:txBody>
+          <a:bodyPr wrap="square">
+            <a:spAutoFit/>
+          </a:bodyPr>
+          <a:lstStyle/>
+          <a:p>
+            <a:pPr>
+              <a:spcBef>
+                <a:spcPts val="200"/>
+              </a:spcBef>
+              <a:spcAft>
+                <a:spcPts val="200"/>
+              </a:spcAft>
+              <a:defRPr sz="850">
+                <a:solidFill>
+                  <a:srgbClr val="0D1B2A"/>
+                </a:solidFill>
+              </a:defRPr>
+            </a:pPr>
+            <a:r>
+              <a:t>• Professional channel strategy</a:t>
+            </a:r>
+            <a:br/>
+            <a:r>
+              <a:t>• Everyuth mass-budget tier growth</a:t>
+            </a:r>
+            <a:br/>
+            <a:r>
+              <a:t>• Owner: Metro NKAM | Target: ₹8.7 Cr (+21%)</a:t>
+            </a:r>
+          </a:p>
+        </p:txBody>
+      </p:sp>
+    </p:spTree>
+  </p:cSld>
+  <p:clrMapOvr>
+    <a:masterClrMapping/>
+  </p:clrMapOvr>
+</p:sld>
+</file>
+
+<file path=ppt/slides/slide7.xml><?xml version="1.0" encoding="utf-8"?>
+<p:sld xmlns:a="http://schemas.openxmlformats.org/drawingml/2006/main" xmlns:p="http://schemas.openxmlformats.org/presentationml/2006/main" xmlns:r="http://schemas.openxmlformats.org/officeDocument/2006/relationships">
+  <p:cSld>
+    <p:bg>
+      <p:bgPr>
+        <a:solidFill>
+          <a:srgbClr val="FFFFFF"/>
+        </a:solidFill>
+        <a:effectLst/>
+      </p:bgPr>
+    </p:bg>
+    <p:spTree>
+      <p:nvGrpSpPr>
+        <p:cNvPr id="1" name=""/>
+        <p:cNvGrpSpPr/>
+        <p:nvPr/>
+      </p:nvGrpSpPr>
+      <p:grpSpPr/>
+      <p:sp>
+        <p:nvSpPr>
+          <p:cNvPr id="2" name="Rectangle 1"/>
+          <p:cNvSpPr/>
+          <p:nvPr/>
+        </p:nvSpPr>
+        <p:spPr>
+          <a:xfrm>
+            <a:off x="0" y="0"/>
+            <a:ext cx="9144000" cy="731520"/>
+          </a:xfrm>
+          <a:prstGeom prst="rect">
+            <a:avLst/>
+          </a:prstGeom>
+          <a:solidFill>
+            <a:srgbClr val="0D1B2A"/>
+          </a:solidFill>
+          <a:ln/>
+        </p:spPr>
+        <p:style>
+          <a:lnRef idx="1">
+            <a:schemeClr val="accent1"/>
+          </a:lnRef>
+          <a:fillRef idx="3">
+            <a:schemeClr val="accent1"/>
+          </a:fillRef>
+          <a:effectRef idx="2">
+            <a:schemeClr val="accent1"/>
+          </a:effectRef>
+          <a:fontRef idx="minor">
+            <a:schemeClr val="lt1"/>
+          </a:fontRef>
+        </p:style>
+        <p:txBody>
+          <a:bodyPr rtlCol="0" anchor="ctr"/>
+          <a:lstStyle/>
+          <a:p>
+            <a:pPr algn="ctr"/>
+          </a:p>
+        </p:txBody>
+      </p:sp>
+      <p:sp>
+        <p:nvSpPr>
+          <p:cNvPr id="3" name="TextBox 2"/>
+          <p:cNvSpPr txBox="1"/>
+          <p:nvPr/>
+        </p:nvSpPr>
+        <p:spPr>
+          <a:xfrm>
+            <a:off x="457200" y="137160"/>
+            <a:ext cx="8229600" cy="548640"/>
+          </a:xfrm>
+          <a:prstGeom prst="rect">
+            <a:avLst/>
+          </a:prstGeom>
+          <a:noFill/>
+        </p:spPr>
+        <p:txBody>
+          <a:bodyPr wrap="none">
+            <a:spAutoFit/>
+          </a:bodyPr>
+          <a:lstStyle/>
+          <a:p>
+            <a:pPr>
+              <a:defRPr sz="2600" b="1">
+                <a:solidFill>
+                  <a:srgbClr val="FFFFFF"/>
+                </a:solidFill>
+              </a:defRPr>
+            </a:pPr>
+            <a:r>
+              <a:t>Success Metrics: Aug Target vs. Ownership</a:t>
+            </a:r>
+          </a:p>
+        </p:txBody>
+      </p:sp>
+      <p:sp>
+        <p:nvSpPr>
+          <p:cNvPr id="4" name="Rectangle 3"/>
+          <p:cNvSpPr/>
+          <p:nvPr/>
+        </p:nvSpPr>
+        <p:spPr>
+          <a:xfrm>
+            <a:off x="457200" y="1097280"/>
+            <a:ext cx="1005840" cy="274320"/>
+          </a:xfrm>
+          <a:prstGeom prst="rect">
+            <a:avLst/>
+          </a:prstGeom>
+          <a:solidFill>
+            <a:srgbClr val="0D1B2A"/>
+          </a:solidFill>
+          <a:ln w="6350">
+            <a:solidFill>
+              <a:srgbClr val="0D1B2A"/>
+            </a:solidFill>
+          </a:ln>
+        </p:spPr>
+        <p:style>
+          <a:lnRef idx="1">
+            <a:schemeClr val="accent1"/>
+          </a:lnRef>
+          <a:fillRef idx="3">
+            <a:schemeClr val="accent1"/>
+          </a:fillRef>
+          <a:effectRef idx="2">
+            <a:schemeClr val="accent1"/>
+          </a:effectRef>
+          <a:fontRef idx="minor">
+            <a:schemeClr val="lt1"/>
+          </a:fontRef>
+        </p:style>
+        <p:txBody>
+          <a:bodyPr rtlCol="0" anchor="ctr"/>
+          <a:lstStyle/>
+          <a:p>
+            <a:pPr algn="ctr">
+              <a:defRPr b="1" sz="900">
+                <a:solidFill>
+                  <a:srgbClr val="FFFFFF"/>
+                </a:solidFill>
+              </a:defRPr>
+            </a:pPr>
+            <a:r>
+              <a:t>Owner Type</a:t>
+            </a:r>
+          </a:p>
+        </p:txBody>
+      </p:sp>
+      <p:sp>
+        <p:nvSpPr>
+          <p:cNvPr id="5" name="Rectangle 4"/>
+          <p:cNvSpPr/>
+          <p:nvPr/>
+        </p:nvSpPr>
+        <p:spPr>
+          <a:xfrm>
+            <a:off x="1463040" y="1097280"/>
+            <a:ext cx="1188720" cy="274320"/>
+          </a:xfrm>
+          <a:prstGeom prst="rect">
+            <a:avLst/>
+          </a:prstGeom>
+          <a:solidFill>
+            <a:srgbClr val="0D1B2A"/>
+          </a:solidFill>
+          <a:ln w="6350">
+            <a:solidFill>
+              <a:srgbClr val="0D1B2A"/>
+            </a:solidFill>
+          </a:ln>
+        </p:spPr>
+        <p:style>
+          <a:lnRef idx="1">
+            <a:schemeClr val="accent1"/>
+          </a:lnRef>
+          <a:fillRef idx="3">
+            <a:schemeClr val="accent1"/>
+          </a:fillRef>
+          <a:effectRef idx="2">
+            <a:schemeClr val="accent1"/>
+          </a:effectRef>
+          <a:fontRef idx="minor">
+            <a:schemeClr val="lt1"/>
+          </a:fontRef>
+        </p:style>
+        <p:txBody>
+          <a:bodyPr rtlCol="0" anchor="ctr"/>
+          <a:lstStyle/>
+          <a:p>
+            <a:pPr algn="ctr">
+              <a:defRPr b="1" sz="900">
+                <a:solidFill>
+                  <a:srgbClr val="FFFFFF"/>
+                </a:solidFill>
+              </a:defRPr>
+            </a:pPr>
+            <a:r>
+              <a:t>Entity</a:t>
+            </a:r>
+          </a:p>
+        </p:txBody>
+      </p:sp>
+      <p:sp>
+        <p:nvSpPr>
+          <p:cNvPr id="6" name="Rectangle 5"/>
+          <p:cNvSpPr/>
+          <p:nvPr/>
+        </p:nvSpPr>
+        <p:spPr>
+          <a:xfrm>
+            <a:off x="2651760" y="1097280"/>
+            <a:ext cx="1188720" cy="274320"/>
+          </a:xfrm>
+          <a:prstGeom prst="rect">
+            <a:avLst/>
+          </a:prstGeom>
+          <a:solidFill>
+            <a:srgbClr val="0D1B2A"/>
+          </a:solidFill>
+          <a:ln w="6350">
+            <a:solidFill>
+              <a:srgbClr val="0D1B2A"/>
+            </a:solidFill>
+          </a:ln>
+        </p:spPr>
+        <p:style>
+          <a:lnRef idx="1">
+            <a:schemeClr val="accent1"/>
+          </a:lnRef>
+          <a:fillRef idx="3">
+            <a:schemeClr val="accent1"/>
+          </a:fillRef>
+          <a:effectRef idx="2">
+            <a:schemeClr val="accent1"/>
+          </a:effectRef>
+          <a:fontRef idx="minor">
+            <a:schemeClr val="lt1"/>
+          </a:fontRef>
+        </p:style>
+        <p:txBody>
+          <a:bodyPr rtlCol="0" anchor="ctr"/>
+          <a:lstStyle/>
+          <a:p>
+            <a:pPr algn="ctr">
+              <a:defRPr b="1" sz="900">
+                <a:solidFill>
+                  <a:srgbClr val="FFFFFF"/>
+                </a:solidFill>
+              </a:defRPr>
+            </a:pPr>
+            <a:r>
+              <a:t>Jul Baseline</a:t>
+            </a:r>
+          </a:p>
+        </p:txBody>
+      </p:sp>
+      <p:sp>
+        <p:nvSpPr>
+          <p:cNvPr id="7" name="Rectangle 6"/>
+          <p:cNvSpPr/>
+          <p:nvPr/>
+        </p:nvSpPr>
+        <p:spPr>
+          <a:xfrm>
+            <a:off x="3840480" y="1097280"/>
+            <a:ext cx="1280160" cy="274320"/>
+          </a:xfrm>
+          <a:prstGeom prst="rect">
+            <a:avLst/>
+          </a:prstGeom>
+          <a:solidFill>
+            <a:srgbClr val="0D1B2A"/>
+          </a:solidFill>
+          <a:ln w="6350">
+            <a:solidFill>
+              <a:srgbClr val="0D1B2A"/>
+            </a:solidFill>
+          </a:ln>
+        </p:spPr>
+        <p:style>
+          <a:lnRef idx="1">
+            <a:schemeClr val="accent1"/>
+          </a:lnRef>
+          <a:fillRef idx="3">
+            <a:schemeClr val="accent1"/>
+          </a:fillRef>
+          <a:effectRef idx="2">
+            <a:schemeClr val="accent1"/>
+          </a:effectRef>
+          <a:fontRef idx="minor">
+            <a:schemeClr val="lt1"/>
+          </a:fontRef>
+        </p:style>
+        <p:txBody>
+          <a:bodyPr rtlCol="0" anchor="ctr"/>
+          <a:lstStyle/>
+          <a:p>
+            <a:pPr algn="ctr">
+              <a:defRPr b="1" sz="900">
+                <a:solidFill>
+                  <a:srgbClr val="FFFFFF"/>
+                </a:solidFill>
+              </a:defRPr>
+            </a:pPr>
+            <a:r>
+              <a:t>Aug Target</a:t>
+            </a:r>
+          </a:p>
+        </p:txBody>
+      </p:sp>
+      <p:sp>
+        <p:nvSpPr>
+          <p:cNvPr id="8" name="Rectangle 7"/>
+          <p:cNvSpPr/>
+          <p:nvPr/>
+        </p:nvSpPr>
+        <p:spPr>
+          <a:xfrm>
+            <a:off x="5120640" y="1097280"/>
+            <a:ext cx="1097280" cy="274320"/>
+          </a:xfrm>
+          <a:prstGeom prst="rect">
+            <a:avLst/>
+          </a:prstGeom>
+          <a:solidFill>
+            <a:srgbClr val="0D1B2A"/>
+          </a:solidFill>
+          <a:ln w="6350">
+            <a:solidFill>
+              <a:srgbClr val="0D1B2A"/>
+            </a:solidFill>
+          </a:ln>
+        </p:spPr>
+        <p:style>
+          <a:lnRef idx="1">
+            <a:schemeClr val="accent1"/>
+          </a:lnRef>
+          <a:fillRef idx="3">
+            <a:schemeClr val="accent1"/>
+          </a:fillRef>
+          <a:effectRef idx="2">
+            <a:schemeClr val="accent1"/>
+          </a:effectRef>
+          <a:fontRef idx="minor">
+            <a:schemeClr val="lt1"/>
+          </a:fontRef>
+        </p:style>
+        <p:txBody>
+          <a:bodyPr rtlCol="0" anchor="ctr"/>
+          <a:lstStyle/>
+          <a:p>
+            <a:pPr algn="ctr">
+              <a:defRPr b="1" sz="900">
+                <a:solidFill>
+                  <a:srgbClr val="FFFFFF"/>
+                </a:solidFill>
+              </a:defRPr>
+            </a:pPr>
+            <a:r>
+              <a:t>Growth %</a:t>
+            </a:r>
+          </a:p>
+        </p:txBody>
+      </p:sp>
+      <p:sp>
+        <p:nvSpPr>
+          <p:cNvPr id="9" name="Rectangle 8"/>
+          <p:cNvSpPr/>
+          <p:nvPr/>
+        </p:nvSpPr>
+        <p:spPr>
+          <a:xfrm>
+            <a:off x="6217920" y="1097280"/>
+            <a:ext cx="1554480" cy="274320"/>
+          </a:xfrm>
+          <a:prstGeom prst="rect">
+            <a:avLst/>
+          </a:prstGeom>
+          <a:solidFill>
+            <a:srgbClr val="0D1B2A"/>
+          </a:solidFill>
+          <a:ln w="6350">
+            <a:solidFill>
+              <a:srgbClr val="0D1B2A"/>
+            </a:solidFill>
+          </a:ln>
+        </p:spPr>
+        <p:style>
+          <a:lnRef idx="1">
+            <a:schemeClr val="accent1"/>
+          </a:lnRef>
+          <a:fillRef idx="3">
+            <a:schemeClr val="accent1"/>
+          </a:fillRef>
+          <a:effectRef idx="2">
+            <a:schemeClr val="accent1"/>
+          </a:effectRef>
+          <a:fontRef idx="minor">
+            <a:schemeClr val="lt1"/>
+          </a:fontRef>
+        </p:style>
+        <p:txBody>
+          <a:bodyPr rtlCol="0" anchor="ctr"/>
+          <a:lstStyle/>
+          <a:p>
+            <a:pPr algn="ctr">
+              <a:defRPr b="1" sz="900">
+                <a:solidFill>
+                  <a:srgbClr val="FFFFFF"/>
+                </a:solidFill>
+              </a:defRPr>
+            </a:pPr>
+            <a:r>
+              <a:t>Review Date</a:t>
+            </a:r>
+          </a:p>
+        </p:txBody>
+      </p:sp>
+      <p:sp>
+        <p:nvSpPr>
+          <p:cNvPr id="10" name="Rectangle 9"/>
+          <p:cNvSpPr/>
+          <p:nvPr/>
+        </p:nvSpPr>
+        <p:spPr>
+          <a:xfrm>
+            <a:off x="457200" y="1371600"/>
+            <a:ext cx="8229600" cy="274320"/>
+          </a:xfrm>
+          <a:prstGeom prst="rect">
+            <a:avLst/>
+          </a:prstGeom>
+          <a:solidFill>
+            <a:srgbClr val="F5F5F5"/>
+          </a:solidFill>
+          <a:ln/>
+        </p:spPr>
+        <p:style>
+          <a:lnRef idx="1">
+            <a:schemeClr val="accent1"/>
+          </a:lnRef>
+          <a:fillRef idx="3">
+            <a:schemeClr val="accent1"/>
+          </a:fillRef>
+          <a:effectRef idx="2">
+            <a:schemeClr val="accent1"/>
+          </a:effectRef>
+          <a:fontRef idx="minor">
+            <a:schemeClr val="lt1"/>
+          </a:fontRef>
+        </p:style>
+        <p:txBody>
+          <a:bodyPr rtlCol="0" anchor="ctr"/>
+          <a:lstStyle/>
+          <a:p>
+            <a:pPr algn="ctr"/>
+          </a:p>
+        </p:txBody>
+      </p:sp>
+      <p:sp>
+        <p:nvSpPr>
+          <p:cNvPr id="11" name="Rectangle 10"/>
+          <p:cNvSpPr/>
+          <p:nvPr/>
+        </p:nvSpPr>
+        <p:spPr>
+          <a:xfrm>
+            <a:off x="457200" y="1371600"/>
+            <a:ext cx="1005840" cy="274320"/>
+          </a:xfrm>
+          <a:prstGeom prst="rect">
+            <a:avLst/>
+          </a:prstGeom>
+          <a:solidFill>
+            <a:srgbClr val="FFFFFF"/>
+          </a:solidFill>
+          <a:ln w="6350">
+            <a:solidFill>
+              <a:srgbClr val="959595"/>
+            </a:solidFill>
+          </a:ln>
+        </p:spPr>
+        <p:style>
+          <a:lnRef idx="1">
+            <a:schemeClr val="accent1"/>
+          </a:lnRef>
+          <a:fillRef idx="3">
+            <a:schemeClr val="accent1"/>
+          </a:fillRef>
+          <a:effectRef idx="2">
+            <a:schemeClr val="accent1"/>
+          </a:effectRef>
+          <a:fontRef idx="minor">
+            <a:schemeClr val="lt1"/>
+          </a:fontRef>
+        </p:style>
+        <p:txBody>
+          <a:bodyPr rtlCol="0" anchor="ctr"/>
+          <a:lstStyle/>
+          <a:p>
+            <a:pPr algn="ctr">
+              <a:defRPr sz="850" b="1">
+                <a:solidFill>
+                  <a:srgbClr val="7B2CBA"/>
+                </a:solidFill>
+              </a:defRPr>
+            </a:pPr>
+            <a:r>
+              <a:t>RKAM</a:t>
+            </a:r>
+          </a:p>
+        </p:txBody>
+      </p:sp>
+      <p:sp>
+        <p:nvSpPr>
+          <p:cNvPr id="12" name="Rectangle 11"/>
+          <p:cNvSpPr/>
+          <p:nvPr/>
+        </p:nvSpPr>
+        <p:spPr>
+          <a:xfrm>
+            <a:off x="1463040" y="1371600"/>
+            <a:ext cx="1188720" cy="274320"/>
+          </a:xfrm>
+          <a:prstGeom prst="rect">
+            <a:avLst/>
+          </a:prstGeom>
+          <a:solidFill>
+            <a:srgbClr val="FFFFFF"/>
+          </a:solidFill>
+          <a:ln w="6350">
+            <a:solidFill>
+              <a:srgbClr val="959595"/>
+            </a:solidFill>
+          </a:ln>
+        </p:spPr>
+        <p:style>
+          <a:lnRef idx="1">
+            <a:schemeClr val="accent1"/>
+          </a:lnRef>
+          <a:fillRef idx="3">
+            <a:schemeClr val="accent1"/>
+          </a:fillRef>
+          <a:effectRef idx="2">
+            <a:schemeClr val="accent1"/>
+          </a:effectRef>
+          <a:fontRef idx="minor">
+            <a:schemeClr val="lt1"/>
+          </a:fontRef>
+        </p:style>
+        <p:txBody>
+          <a:bodyPr rtlCol="0" anchor="ctr"/>
+          <a:lstStyle/>
+          <a:p>
+            <a:pPr algn="l">
+              <a:defRPr sz="850"/>
+            </a:pPr>
+            <a:r>
+              <a:t>North Region</a:t>
+            </a:r>
+          </a:p>
+        </p:txBody>
+      </p:sp>
+      <p:sp>
+        <p:nvSpPr>
+          <p:cNvPr id="13" name="Rectangle 12"/>
+          <p:cNvSpPr/>
+          <p:nvPr/>
+        </p:nvSpPr>
+        <p:spPr>
+          <a:xfrm>
+            <a:off x="2651760" y="1371600"/>
+            <a:ext cx="1188720" cy="274320"/>
+          </a:xfrm>
+          <a:prstGeom prst="rect">
+            <a:avLst/>
+          </a:prstGeom>
+          <a:solidFill>
+            <a:srgbClr val="FFFFFF"/>
+          </a:solidFill>
+          <a:ln w="6350">
+            <a:solidFill>
+              <a:srgbClr val="959595"/>
+            </a:solidFill>
+          </a:ln>
+        </p:spPr>
+        <p:style>
+          <a:lnRef idx="1">
+            <a:schemeClr val="accent1"/>
+          </a:lnRef>
+          <a:fillRef idx="3">
+            <a:schemeClr val="accent1"/>
+          </a:fillRef>
+          <a:effectRef idx="2">
+            <a:schemeClr val="accent1"/>
+          </a:effectRef>
+          <a:fontRef idx="minor">
+            <a:schemeClr val="lt1"/>
+          </a:fontRef>
+        </p:style>
+        <p:txBody>
+          <a:bodyPr rtlCol="0" anchor="ctr"/>
+          <a:lstStyle/>
+          <a:p>
+            <a:pPr algn="ctr">
+              <a:defRPr sz="850"/>
+            </a:pPr>
+            <a:r>
+              <a:t>₹68.2 Cr</a:t>
+            </a:r>
+          </a:p>
+        </p:txBody>
+      </p:sp>
+      <p:sp>
+        <p:nvSpPr>
+          <p:cNvPr id="14" name="Rectangle 13"/>
+          <p:cNvSpPr/>
+          <p:nvPr/>
+        </p:nvSpPr>
+        <p:spPr>
+          <a:xfrm>
+            <a:off x="3840480" y="1371600"/>
+            <a:ext cx="1280160" cy="274320"/>
+          </a:xfrm>
+          <a:prstGeom prst="rect">
+            <a:avLst/>
+          </a:prstGeom>
+          <a:solidFill>
+            <a:srgbClr val="FFFFFF"/>
+          </a:solidFill>
+          <a:ln w="6350">
+            <a:solidFill>
+              <a:srgbClr val="959595"/>
+            </a:solidFill>
+          </a:ln>
+        </p:spPr>
+        <p:style>
+          <a:lnRef idx="1">
+            <a:schemeClr val="accent1"/>
+          </a:lnRef>
+          <a:fillRef idx="3">
+            <a:schemeClr val="accent1"/>
+          </a:fillRef>
+          <a:effectRef idx="2">
+            <a:schemeClr val="accent1"/>
+          </a:effectRef>
+          <a:fontRef idx="minor">
+            <a:schemeClr val="lt1"/>
+          </a:fontRef>
+        </p:style>
+        <p:txBody>
+          <a:bodyPr rtlCol="0" anchor="ctr"/>
+          <a:lstStyle/>
+          <a:p>
+            <a:pPr algn="ctr">
+              <a:defRPr sz="850"/>
+            </a:pPr>
+            <a:r>
+              <a:t>₹76.8 Cr</a:t>
+            </a:r>
+          </a:p>
+        </p:txBody>
+      </p:sp>
+      <p:sp>
+        <p:nvSpPr>
+          <p:cNvPr id="15" name="Rectangle 14"/>
+          <p:cNvSpPr/>
+          <p:nvPr/>
+        </p:nvSpPr>
+        <p:spPr>
+          <a:xfrm>
+            <a:off x="5120640" y="1371600"/>
+            <a:ext cx="1097280" cy="274320"/>
+          </a:xfrm>
+          <a:prstGeom prst="rect">
+            <a:avLst/>
+          </a:prstGeom>
+          <a:solidFill>
+            <a:srgbClr val="FFFFFF"/>
+          </a:solidFill>
+          <a:ln w="6350">
+            <a:solidFill>
+              <a:srgbClr val="959595"/>
+            </a:solidFill>
+          </a:ln>
+        </p:spPr>
+        <p:style>
+          <a:lnRef idx="1">
+            <a:schemeClr val="accent1"/>
+          </a:lnRef>
+          <a:fillRef idx="3">
+            <a:schemeClr val="accent1"/>
+          </a:fillRef>
+          <a:effectRef idx="2">
+            <a:schemeClr val="accent1"/>
+          </a:effectRef>
+          <a:fontRef idx="minor">
+            <a:schemeClr val="lt1"/>
+          </a:fontRef>
+        </p:style>
+        <p:txBody>
+          <a:bodyPr rtlCol="0" anchor="ctr"/>
+          <a:lstStyle/>
+          <a:p>
+            <a:pPr algn="ctr">
+              <a:defRPr sz="850" b="1">
+                <a:solidFill>
+                  <a:srgbClr val="2A9D8F"/>
+                </a:solidFill>
+              </a:defRPr>
+            </a:pPr>
+            <a:r>
+              <a:t>+12.6%</a:t>
+            </a:r>
+          </a:p>
+        </p:txBody>
+      </p:sp>
+      <p:sp>
+        <p:nvSpPr>
+          <p:cNvPr id="16" name="Rectangle 15"/>
+          <p:cNvSpPr/>
+          <p:nvPr/>
+        </p:nvSpPr>
+        <p:spPr>
+          <a:xfrm>
+            <a:off x="6217920" y="1371600"/>
+            <a:ext cx="1554480" cy="274320"/>
+          </a:xfrm>
+          <a:prstGeom prst="rect">
+            <a:avLst/>
+          </a:prstGeom>
+          <a:solidFill>
+            <a:srgbClr val="FFFFFF"/>
+          </a:solidFill>
+          <a:ln w="6350">
+            <a:solidFill>
+              <a:srgbClr val="959595"/>
+            </a:solidFill>
+          </a:ln>
+        </p:spPr>
+        <p:style>
+          <a:lnRef idx="1">
+            <a:schemeClr val="accent1"/>
+          </a:lnRef>
+          <a:fillRef idx="3">
+            <a:schemeClr val="accent1"/>
+          </a:fillRef>
+          <a:effectRef idx="2">
+            <a:schemeClr val="accent1"/>
+          </a:effectRef>
+          <a:fontRef idx="minor">
+            <a:schemeClr val="lt1"/>
+          </a:fontRef>
+        </p:style>
+        <p:txBody>
+          <a:bodyPr rtlCol="0" anchor="ctr"/>
+          <a:lstStyle/>
+          <a:p>
+            <a:pPr algn="ctr">
+              <a:defRPr sz="850"/>
+            </a:pPr>
+            <a:r>
+              <a:t>22-Aug</a:t>
+            </a:r>
+          </a:p>
+        </p:txBody>
+      </p:sp>
+      <p:sp>
+        <p:nvSpPr>
+          <p:cNvPr id="17" name="Rectangle 16"/>
+          <p:cNvSpPr/>
+          <p:nvPr/>
+        </p:nvSpPr>
+        <p:spPr>
+          <a:xfrm>
+            <a:off x="457200" y="1645920"/>
+            <a:ext cx="1005840" cy="274320"/>
+          </a:xfrm>
+          <a:prstGeom prst="rect">
+            <a:avLst/>
+          </a:prstGeom>
+          <a:solidFill>
+            <a:srgbClr val="FFFFFF"/>
+          </a:solidFill>
+          <a:ln w="6350">
+            <a:solidFill>
+              <a:srgbClr val="959595"/>
+            </a:solidFill>
+          </a:ln>
+        </p:spPr>
+        <p:style>
+          <a:lnRef idx="1">
+            <a:schemeClr val="accent1"/>
+          </a:lnRef>
+          <a:fillRef idx="3">
+            <a:schemeClr val="accent1"/>
+          </a:fillRef>
+          <a:effectRef idx="2">
+            <a:schemeClr val="accent1"/>
+          </a:effectRef>
+          <a:fontRef idx="minor">
+            <a:schemeClr val="lt1"/>
+          </a:fontRef>
+        </p:style>
+        <p:txBody>
+          <a:bodyPr rtlCol="0" anchor="ctr"/>
+          <a:lstStyle/>
+          <a:p>
+            <a:pPr algn="ctr">
+              <a:defRPr sz="850" b="1">
+                <a:solidFill>
+                  <a:srgbClr val="7B2CBA"/>
+                </a:solidFill>
+              </a:defRPr>
+            </a:pPr>
+            <a:r>
+              <a:t>RKAM</a:t>
+            </a:r>
+          </a:p>
+        </p:txBody>
+      </p:sp>
+      <p:sp>
+        <p:nvSpPr>
+          <p:cNvPr id="18" name="Rectangle 17"/>
+          <p:cNvSpPr/>
+          <p:nvPr/>
+        </p:nvSpPr>
+        <p:spPr>
+          <a:xfrm>
+            <a:off x="1463040" y="1645920"/>
+            <a:ext cx="1188720" cy="274320"/>
+          </a:xfrm>
+          <a:prstGeom prst="rect">
+            <a:avLst/>
+          </a:prstGeom>
+          <a:solidFill>
+            <a:srgbClr val="FFFFFF"/>
+          </a:solidFill>
+          <a:ln w="6350">
+            <a:solidFill>
+              <a:srgbClr val="959595"/>
+            </a:solidFill>
+          </a:ln>
+        </p:spPr>
+        <p:style>
+          <a:lnRef idx="1">
+            <a:schemeClr val="accent1"/>
+          </a:lnRef>
+          <a:fillRef idx="3">
+            <a:schemeClr val="accent1"/>
+          </a:fillRef>
+          <a:effectRef idx="2">
+            <a:schemeClr val="accent1"/>
+          </a:effectRef>
+          <a:fontRef idx="minor">
+            <a:schemeClr val="lt1"/>
+          </a:fontRef>
+        </p:style>
+        <p:txBody>
+          <a:bodyPr rtlCol="0" anchor="ctr"/>
+          <a:lstStyle/>
+          <a:p>
+            <a:pPr algn="l">
+              <a:defRPr sz="850"/>
+            </a:pPr>
+            <a:r>
+              <a:t>South-1 Region</a:t>
+            </a:r>
+          </a:p>
+        </p:txBody>
+      </p:sp>
+      <p:sp>
+        <p:nvSpPr>
+          <p:cNvPr id="19" name="Rectangle 18"/>
+          <p:cNvSpPr/>
+          <p:nvPr/>
+        </p:nvSpPr>
+        <p:spPr>
+          <a:xfrm>
+            <a:off x="2651760" y="1645920"/>
+            <a:ext cx="1188720" cy="274320"/>
+          </a:xfrm>
+          <a:prstGeom prst="rect">
+            <a:avLst/>
+          </a:prstGeom>
+          <a:solidFill>
+            <a:srgbClr val="FFFFFF"/>
+          </a:solidFill>
+          <a:ln w="6350">
+            <a:solidFill>
+              <a:srgbClr val="959595"/>
+            </a:solidFill>
+          </a:ln>
+        </p:spPr>
+        <p:style>
+          <a:lnRef idx="1">
+            <a:schemeClr val="accent1"/>
+          </a:lnRef>
+          <a:fillRef idx="3">
+            <a:schemeClr val="accent1"/>
+          </a:fillRef>
+          <a:effectRef idx="2">
+            <a:schemeClr val="accent1"/>
+          </a:effectRef>
+          <a:fontRef idx="minor">
+            <a:schemeClr val="lt1"/>
+          </a:fontRef>
+        </p:style>
+        <p:txBody>
+          <a:bodyPr rtlCol="0" anchor="ctr"/>
+          <a:lstStyle/>
+          <a:p>
+            <a:pPr algn="ctr">
+              <a:defRPr sz="850"/>
+            </a:pPr>
+            <a:r>
+              <a:t>₹71.3 Cr</a:t>
+            </a:r>
+          </a:p>
+        </p:txBody>
+      </p:sp>
+      <p:sp>
+        <p:nvSpPr>
+          <p:cNvPr id="20" name="Rectangle 19"/>
+          <p:cNvSpPr/>
+          <p:nvPr/>
+        </p:nvSpPr>
+        <p:spPr>
+          <a:xfrm>
+            <a:off x="3840480" y="1645920"/>
+            <a:ext cx="1280160" cy="274320"/>
+          </a:xfrm>
+          <a:prstGeom prst="rect">
+            <a:avLst/>
+          </a:prstGeom>
+          <a:solidFill>
+            <a:srgbClr val="FFFFFF"/>
+          </a:solidFill>
+          <a:ln w="6350">
+            <a:solidFill>
+              <a:srgbClr val="959595"/>
+            </a:solidFill>
+          </a:ln>
+        </p:spPr>
+        <p:style>
+          <a:lnRef idx="1">
+            <a:schemeClr val="accent1"/>
+          </a:lnRef>
+          <a:fillRef idx="3">
+            <a:schemeClr val="accent1"/>
+          </a:fillRef>
+          <a:effectRef idx="2">
+            <a:schemeClr val="accent1"/>
+          </a:effectRef>
+          <a:fontRef idx="minor">
+            <a:schemeClr val="lt1"/>
+          </a:fontRef>
+        </p:style>
+        <p:txBody>
+          <a:bodyPr rtlCol="0" anchor="ctr"/>
+          <a:lstStyle/>
+          <a:p>
+            <a:pPr algn="ctr">
+              <a:defRPr sz="850"/>
+            </a:pPr>
+            <a:r>
+              <a:t>₹82.1 Cr</a:t>
+            </a:r>
+          </a:p>
+        </p:txBody>
+      </p:sp>
+      <p:sp>
+        <p:nvSpPr>
+          <p:cNvPr id="21" name="Rectangle 20"/>
+          <p:cNvSpPr/>
+          <p:nvPr/>
+        </p:nvSpPr>
+        <p:spPr>
+          <a:xfrm>
+            <a:off x="5120640" y="1645920"/>
+            <a:ext cx="1097280" cy="274320"/>
+          </a:xfrm>
+          <a:prstGeom prst="rect">
+            <a:avLst/>
+          </a:prstGeom>
+          <a:solidFill>
+            <a:srgbClr val="FFFFFF"/>
+          </a:solidFill>
+          <a:ln w="6350">
+            <a:solidFill>
+              <a:srgbClr val="959595"/>
+            </a:solidFill>
+          </a:ln>
+        </p:spPr>
+        <p:style>
+          <a:lnRef idx="1">
+            <a:schemeClr val="accent1"/>
+          </a:lnRef>
+          <a:fillRef idx="3">
+            <a:schemeClr val="accent1"/>
+          </a:fillRef>
+          <a:effectRef idx="2">
+            <a:schemeClr val="accent1"/>
+          </a:effectRef>
+          <a:fontRef idx="minor">
+            <a:schemeClr val="lt1"/>
+          </a:fontRef>
+        </p:style>
+        <p:txBody>
+          <a:bodyPr rtlCol="0" anchor="ctr"/>
+          <a:lstStyle/>
+          <a:p>
+            <a:pPr algn="ctr">
+              <a:defRPr sz="850" b="1">
+                <a:solidFill>
+                  <a:srgbClr val="2A9D8F"/>
+                </a:solidFill>
+              </a:defRPr>
+            </a:pPr>
+            <a:r>
+              <a:t>+15.2%</a:t>
+            </a:r>
+          </a:p>
+        </p:txBody>
+      </p:sp>
+      <p:sp>
+        <p:nvSpPr>
+          <p:cNvPr id="22" name="Rectangle 21"/>
+          <p:cNvSpPr/>
+          <p:nvPr/>
+        </p:nvSpPr>
+        <p:spPr>
+          <a:xfrm>
+            <a:off x="6217920" y="1645920"/>
+            <a:ext cx="1554480" cy="274320"/>
+          </a:xfrm>
+          <a:prstGeom prst="rect">
+            <a:avLst/>
+          </a:prstGeom>
+          <a:solidFill>
+            <a:srgbClr val="FFFFFF"/>
+          </a:solidFill>
+          <a:ln w="6350">
+            <a:solidFill>
+              <a:srgbClr val="959595"/>
+            </a:solidFill>
+          </a:ln>
+        </p:spPr>
+        <p:style>
+          <a:lnRef idx="1">
+            <a:schemeClr val="accent1"/>
+          </a:lnRef>
+          <a:fillRef idx="3">
+            <a:schemeClr val="accent1"/>
+          </a:fillRef>
+          <a:effectRef idx="2">
+            <a:schemeClr val="accent1"/>
+          </a:effectRef>
+          <a:fontRef idx="minor">
+            <a:schemeClr val="lt1"/>
+          </a:fontRef>
+        </p:style>
+        <p:txBody>
+          <a:bodyPr rtlCol="0" anchor="ctr"/>
+          <a:lstStyle/>
+          <a:p>
+            <a:pPr algn="ctr">
+              <a:defRPr sz="850"/>
+            </a:pPr>
+            <a:r>
+              <a:t>25-Aug</a:t>
+            </a:r>
+          </a:p>
+        </p:txBody>
+      </p:sp>
+      <p:sp>
+        <p:nvSpPr>
+          <p:cNvPr id="23" name="Rectangle 22"/>
+          <p:cNvSpPr/>
+          <p:nvPr/>
+        </p:nvSpPr>
+        <p:spPr>
+          <a:xfrm>
+            <a:off x="457200" y="1920240"/>
+            <a:ext cx="8229600" cy="274320"/>
+          </a:xfrm>
+          <a:prstGeom prst="rect">
+            <a:avLst/>
+          </a:prstGeom>
+          <a:solidFill>
+            <a:srgbClr val="F5F5F5"/>
+          </a:solidFill>
+          <a:ln/>
+        </p:spPr>
+        <p:style>
+          <a:lnRef idx="1">
+            <a:schemeClr val="accent1"/>
+          </a:lnRef>
+          <a:fillRef idx="3">
+            <a:schemeClr val="accent1"/>
+          </a:fillRef>
+          <a:effectRef idx="2">
+            <a:schemeClr val="accent1"/>
+          </a:effectRef>
+          <a:fontRef idx="minor">
+            <a:schemeClr val="lt1"/>
+          </a:fontRef>
+        </p:style>
+        <p:txBody>
+          <a:bodyPr rtlCol="0" anchor="ctr"/>
+          <a:lstStyle/>
+          <a:p>
+            <a:pPr algn="ctr"/>
+          </a:p>
+        </p:txBody>
+      </p:sp>
+      <p:sp>
+        <p:nvSpPr>
+          <p:cNvPr id="24" name="Rectangle 23"/>
+          <p:cNvSpPr/>
+          <p:nvPr/>
+        </p:nvSpPr>
+        <p:spPr>
+          <a:xfrm>
+            <a:off x="457200" y="1920240"/>
+            <a:ext cx="1005840" cy="274320"/>
+          </a:xfrm>
+          <a:prstGeom prst="rect">
+            <a:avLst/>
+          </a:prstGeom>
+          <a:solidFill>
+            <a:srgbClr val="FFFFFF"/>
+          </a:solidFill>
+          <a:ln w="6350">
+            <a:solidFill>
+              <a:srgbClr val="959595"/>
+            </a:solidFill>
+          </a:ln>
+        </p:spPr>
+        <p:style>
+          <a:lnRef idx="1">
+            <a:schemeClr val="accent1"/>
+          </a:lnRef>
+          <a:fillRef idx="3">
+            <a:schemeClr val="accent1"/>
+          </a:fillRef>
+          <a:effectRef idx="2">
+            <a:schemeClr val="accent1"/>
+          </a:effectRef>
+          <a:fontRef idx="minor">
+            <a:schemeClr val="lt1"/>
+          </a:fontRef>
+        </p:style>
+        <p:txBody>
+          <a:bodyPr rtlCol="0" anchor="ctr"/>
+          <a:lstStyle/>
+          <a:p>
+            <a:pPr algn="ctr">
+              <a:defRPr sz="850" b="1">
+                <a:solidFill>
+                  <a:srgbClr val="7B2CBA"/>
+                </a:solidFill>
+              </a:defRPr>
+            </a:pPr>
+            <a:r>
+              <a:t>RKAM</a:t>
+            </a:r>
+          </a:p>
+        </p:txBody>
+      </p:sp>
+      <p:sp>
+        <p:nvSpPr>
+          <p:cNvPr id="25" name="Rectangle 24"/>
+          <p:cNvSpPr/>
+          <p:nvPr/>
+        </p:nvSpPr>
+        <p:spPr>
+          <a:xfrm>
+            <a:off x="1463040" y="1920240"/>
+            <a:ext cx="1188720" cy="274320"/>
+          </a:xfrm>
+          <a:prstGeom prst="rect">
+            <a:avLst/>
+          </a:prstGeom>
+          <a:solidFill>
+            <a:srgbClr val="FFFFFF"/>
+          </a:solidFill>
+          <a:ln w="6350">
+            <a:solidFill>
+              <a:srgbClr val="959595"/>
+            </a:solidFill>
+          </a:ln>
+        </p:spPr>
+        <p:style>
+          <a:lnRef idx="1">
+            <a:schemeClr val="accent1"/>
+          </a:lnRef>
+          <a:fillRef idx="3">
+            <a:schemeClr val="accent1"/>
+          </a:fillRef>
+          <a:effectRef idx="2">
+            <a:schemeClr val="accent1"/>
+          </a:effectRef>
+          <a:fontRef idx="minor">
+            <a:schemeClr val="lt1"/>
+          </a:fontRef>
+        </p:style>
+        <p:txBody>
+          <a:bodyPr rtlCol="0" anchor="ctr"/>
+          <a:lstStyle/>
+          <a:p>
+            <a:pPr algn="l">
+              <a:defRPr sz="850"/>
+            </a:pPr>
+            <a:r>
+              <a:t>South-2 Region</a:t>
+            </a:r>
+          </a:p>
+        </p:txBody>
+      </p:sp>
+      <p:sp>
+        <p:nvSpPr>
+          <p:cNvPr id="26" name="Rectangle 25"/>
+          <p:cNvSpPr/>
+          <p:nvPr/>
+        </p:nvSpPr>
+        <p:spPr>
+          <a:xfrm>
+            <a:off x="2651760" y="1920240"/>
+            <a:ext cx="1188720" cy="274320"/>
+          </a:xfrm>
+          <a:prstGeom prst="rect">
+            <a:avLst/>
+          </a:prstGeom>
+          <a:solidFill>
+            <a:srgbClr val="FFFFFF"/>
+          </a:solidFill>
+          <a:ln w="6350">
+            <a:solidFill>
+              <a:srgbClr val="959595"/>
+            </a:solidFill>
+          </a:ln>
+        </p:spPr>
+        <p:style>
+          <a:lnRef idx="1">
+            <a:schemeClr val="accent1"/>
+          </a:lnRef>
+          <a:fillRef idx="3">
+            <a:schemeClr val="accent1"/>
+          </a:fillRef>
+          <a:effectRef idx="2">
+            <a:schemeClr val="accent1"/>
+          </a:effectRef>
+          <a:fontRef idx="minor">
+            <a:schemeClr val="lt1"/>
+          </a:fontRef>
+        </p:style>
+        <p:txBody>
+          <a:bodyPr rtlCol="0" anchor="ctr"/>
+          <a:lstStyle/>
+          <a:p>
+            <a:pPr algn="ctr">
+              <a:defRPr sz="850"/>
+            </a:pPr>
+            <a:r>
+              <a:t>₹42.1 Cr</a:t>
+            </a:r>
+          </a:p>
+        </p:txBody>
+      </p:sp>
+      <p:sp>
+        <p:nvSpPr>
+          <p:cNvPr id="27" name="Rectangle 26"/>
+          <p:cNvSpPr/>
+          <p:nvPr/>
+        </p:nvSpPr>
+        <p:spPr>
+          <a:xfrm>
+            <a:off x="3840480" y="1920240"/>
+            <a:ext cx="1280160" cy="274320"/>
+          </a:xfrm>
+          <a:prstGeom prst="rect">
+            <a:avLst/>
+          </a:prstGeom>
+          <a:solidFill>
+            <a:srgbClr val="FFFFFF"/>
+          </a:solidFill>
+          <a:ln w="6350">
+            <a:solidFill>
+              <a:srgbClr val="959595"/>
+            </a:solidFill>
+          </a:ln>
+        </p:spPr>
+        <p:style>
+          <a:lnRef idx="1">
+            <a:schemeClr val="accent1"/>
+          </a:lnRef>
+          <a:fillRef idx="3">
+            <a:schemeClr val="accent1"/>
+          </a:fillRef>
+          <a:effectRef idx="2">
+            <a:schemeClr val="accent1"/>
+          </a:effectRef>
+          <a:fontRef idx="minor">
+            <a:schemeClr val="lt1"/>
+          </a:fontRef>
+        </p:style>
+        <p:txBody>
+          <a:bodyPr rtlCol="0" anchor="ctr"/>
+          <a:lstStyle/>
+          <a:p>
+            <a:pPr algn="ctr">
+              <a:defRPr sz="850"/>
+            </a:pPr>
+            <a:r>
+              <a:t>₹45.6 Cr</a:t>
+            </a:r>
+          </a:p>
+        </p:txBody>
+      </p:sp>
+      <p:sp>
+        <p:nvSpPr>
+          <p:cNvPr id="28" name="Rectangle 27"/>
+          <p:cNvSpPr/>
+          <p:nvPr/>
+        </p:nvSpPr>
+        <p:spPr>
+          <a:xfrm>
+            <a:off x="5120640" y="1920240"/>
+            <a:ext cx="1097280" cy="274320"/>
+          </a:xfrm>
+          <a:prstGeom prst="rect">
+            <a:avLst/>
+          </a:prstGeom>
+          <a:solidFill>
+            <a:srgbClr val="FFFFFF"/>
+          </a:solidFill>
+          <a:ln w="6350">
+            <a:solidFill>
+              <a:srgbClr val="959595"/>
+            </a:solidFill>
+          </a:ln>
+        </p:spPr>
+        <p:style>
+          <a:lnRef idx="1">
+            <a:schemeClr val="accent1"/>
+          </a:lnRef>
+          <a:fillRef idx="3">
+            <a:schemeClr val="accent1"/>
+          </a:fillRef>
+          <a:effectRef idx="2">
+            <a:schemeClr val="accent1"/>
+          </a:effectRef>
+          <a:fontRef idx="minor">
+            <a:schemeClr val="lt1"/>
+          </a:fontRef>
+        </p:style>
+        <p:txBody>
+          <a:bodyPr rtlCol="0" anchor="ctr"/>
+          <a:lstStyle/>
+          <a:p>
+            <a:pPr algn="ctr">
+              <a:defRPr sz="850" b="1">
+                <a:solidFill>
+                  <a:srgbClr val="2A9D8F"/>
+                </a:solidFill>
+              </a:defRPr>
+            </a:pPr>
+            <a:r>
+              <a:t>+8.3%</a:t>
+            </a:r>
+          </a:p>
+        </p:txBody>
+      </p:sp>
+      <p:sp>
+        <p:nvSpPr>
+          <p:cNvPr id="29" name="Rectangle 28"/>
+          <p:cNvSpPr/>
+          <p:nvPr/>
+        </p:nvSpPr>
+        <p:spPr>
+          <a:xfrm>
+            <a:off x="6217920" y="1920240"/>
+            <a:ext cx="1554480" cy="274320"/>
+          </a:xfrm>
+          <a:prstGeom prst="rect">
+            <a:avLst/>
+          </a:prstGeom>
+          <a:solidFill>
+            <a:srgbClr val="FFFFFF"/>
+          </a:solidFill>
+          <a:ln w="6350">
+            <a:solidFill>
+              <a:srgbClr val="959595"/>
+            </a:solidFill>
+          </a:ln>
+        </p:spPr>
+        <p:style>
+          <a:lnRef idx="1">
+            <a:schemeClr val="accent1"/>
+          </a:lnRef>
+          <a:fillRef idx="3">
+            <a:schemeClr val="accent1"/>
+          </a:fillRef>
+          <a:effectRef idx="2">
+            <a:schemeClr val="accent1"/>
+          </a:effectRef>
+          <a:fontRef idx="minor">
+            <a:schemeClr val="lt1"/>
+          </a:fontRef>
+        </p:style>
+        <p:txBody>
+          <a:bodyPr rtlCol="0" anchor="ctr"/>
+          <a:lstStyle/>
+          <a:p>
+            <a:pPr algn="ctr">
+              <a:defRPr sz="850"/>
+            </a:pPr>
+            <a:r>
+              <a:t>20-Aug</a:t>
+            </a:r>
+          </a:p>
+        </p:txBody>
+      </p:sp>
+      <p:sp>
+        <p:nvSpPr>
+          <p:cNvPr id="30" name="Rectangle 29"/>
+          <p:cNvSpPr/>
+          <p:nvPr/>
+        </p:nvSpPr>
+        <p:spPr>
+          <a:xfrm>
+            <a:off x="457200" y="2194560"/>
+            <a:ext cx="1005840" cy="274320"/>
+          </a:xfrm>
+          <a:prstGeom prst="rect">
+            <a:avLst/>
+          </a:prstGeom>
+          <a:solidFill>
+            <a:srgbClr val="FFFFFF"/>
+          </a:solidFill>
+          <a:ln w="6350">
+            <a:solidFill>
+              <a:srgbClr val="959595"/>
+            </a:solidFill>
+          </a:ln>
+        </p:spPr>
+        <p:style>
+          <a:lnRef idx="1">
+            <a:schemeClr val="accent1"/>
+          </a:lnRef>
+          <a:fillRef idx="3">
+            <a:schemeClr val="accent1"/>
+          </a:fillRef>
+          <a:effectRef idx="2">
+            <a:schemeClr val="accent1"/>
+          </a:effectRef>
+          <a:fontRef idx="minor">
+            <a:schemeClr val="lt1"/>
+          </a:fontRef>
+        </p:style>
+        <p:txBody>
+          <a:bodyPr rtlCol="0" anchor="ctr"/>
+          <a:lstStyle/>
+          <a:p>
+            <a:pPr algn="ctr">
+              <a:defRPr sz="850" b="1">
+                <a:solidFill>
+                  <a:srgbClr val="7B2CBA"/>
+                </a:solidFill>
+              </a:defRPr>
+            </a:pPr>
+            <a:r>
+              <a:t>RKAM</a:t>
+            </a:r>
+          </a:p>
+        </p:txBody>
+      </p:sp>
+      <p:sp>
+        <p:nvSpPr>
+          <p:cNvPr id="31" name="Rectangle 30"/>
+          <p:cNvSpPr/>
+          <p:nvPr/>
+        </p:nvSpPr>
+        <p:spPr>
+          <a:xfrm>
+            <a:off x="1463040" y="2194560"/>
+            <a:ext cx="1188720" cy="274320"/>
+          </a:xfrm>
+          <a:prstGeom prst="rect">
+            <a:avLst/>
+          </a:prstGeom>
+          <a:solidFill>
+            <a:srgbClr val="FFFFFF"/>
+          </a:solidFill>
+          <a:ln w="6350">
+            <a:solidFill>
+              <a:srgbClr val="959595"/>
+            </a:solidFill>
+          </a:ln>
+        </p:spPr>
+        <p:style>
+          <a:lnRef idx="1">
+            <a:schemeClr val="accent1"/>
+          </a:lnRef>
+          <a:fillRef idx="3">
+            <a:schemeClr val="accent1"/>
+          </a:fillRef>
+          <a:effectRef idx="2">
+            <a:schemeClr val="accent1"/>
+          </a:effectRef>
+          <a:fontRef idx="minor">
+            <a:schemeClr val="lt1"/>
+          </a:fontRef>
+        </p:style>
+        <p:txBody>
+          <a:bodyPr rtlCol="0" anchor="ctr"/>
+          <a:lstStyle/>
+          <a:p>
+            <a:pPr algn="l">
+              <a:defRPr sz="850"/>
+            </a:pPr>
+            <a:r>
+              <a:t>West Region</a:t>
+            </a:r>
+          </a:p>
+        </p:txBody>
+      </p:sp>
+      <p:sp>
+        <p:nvSpPr>
+          <p:cNvPr id="32" name="Rectangle 31"/>
+          <p:cNvSpPr/>
+          <p:nvPr/>
+        </p:nvSpPr>
+        <p:spPr>
+          <a:xfrm>
+            <a:off x="2651760" y="2194560"/>
+            <a:ext cx="1188720" cy="274320"/>
+          </a:xfrm>
+          <a:prstGeom prst="rect">
+            <a:avLst/>
+          </a:prstGeom>
+          <a:solidFill>
+            <a:srgbClr val="FFFFFF"/>
+          </a:solidFill>
+          <a:ln w="6350">
+            <a:solidFill>
+              <a:srgbClr val="959595"/>
+            </a:solidFill>
+          </a:ln>
+        </p:spPr>
+        <p:style>
+          <a:lnRef idx="1">
+            <a:schemeClr val="accent1"/>
+          </a:lnRef>
+          <a:fillRef idx="3">
+            <a:schemeClr val="accent1"/>
+          </a:fillRef>
+          <a:effectRef idx="2">
+            <a:schemeClr val="accent1"/>
+          </a:effectRef>
+          <a:fontRef idx="minor">
+            <a:schemeClr val="lt1"/>
+          </a:fontRef>
+        </p:style>
+        <p:txBody>
+          <a:bodyPr rtlCol="0" anchor="ctr"/>
+          <a:lstStyle/>
+          <a:p>
+            <a:pPr algn="ctr">
+              <a:defRPr sz="850"/>
+            </a:pPr>
+            <a:r>
+              <a:t>₹48.7 Cr</a:t>
+            </a:r>
+          </a:p>
+        </p:txBody>
+      </p:sp>
+      <p:sp>
+        <p:nvSpPr>
+          <p:cNvPr id="33" name="Rectangle 32"/>
+          <p:cNvSpPr/>
+          <p:nvPr/>
+        </p:nvSpPr>
+        <p:spPr>
+          <a:xfrm>
+            <a:off x="3840480" y="2194560"/>
+            <a:ext cx="1280160" cy="274320"/>
+          </a:xfrm>
+          <a:prstGeom prst="rect">
+            <a:avLst/>
+          </a:prstGeom>
+          <a:solidFill>
+            <a:srgbClr val="FFFFFF"/>
+          </a:solidFill>
+          <a:ln w="6350">
+            <a:solidFill>
+              <a:srgbClr val="959595"/>
+            </a:solidFill>
+          </a:ln>
+        </p:spPr>
+        <p:style>
+          <a:lnRef idx="1">
+            <a:schemeClr val="accent1"/>
+          </a:lnRef>
+          <a:fillRef idx="3">
+            <a:schemeClr val="accent1"/>
+          </a:fillRef>
+          <a:effectRef idx="2">
+            <a:schemeClr val="accent1"/>
+          </a:effectRef>
+          <a:fontRef idx="minor">
+            <a:schemeClr val="lt1"/>
+          </a:fontRef>
+        </p:style>
+        <p:txBody>
+          <a:bodyPr rtlCol="0" anchor="ctr"/>
+          <a:lstStyle/>
+          <a:p>
+            <a:pPr algn="ctr">
+              <a:defRPr sz="850"/>
+            </a:pPr>
+            <a:r>
+              <a:t>₹53.6 Cr</a:t>
+            </a:r>
+          </a:p>
+        </p:txBody>
+      </p:sp>
+      <p:sp>
+        <p:nvSpPr>
+          <p:cNvPr id="34" name="Rectangle 33"/>
+          <p:cNvSpPr/>
+          <p:nvPr/>
+        </p:nvSpPr>
+        <p:spPr>
+          <a:xfrm>
+            <a:off x="5120640" y="2194560"/>
+            <a:ext cx="1097280" cy="274320"/>
+          </a:xfrm>
+          <a:prstGeom prst="rect">
+            <a:avLst/>
+          </a:prstGeom>
+          <a:solidFill>
+            <a:srgbClr val="FFFFFF"/>
+          </a:solidFill>
+          <a:ln w="6350">
+            <a:solidFill>
+              <a:srgbClr val="959595"/>
+            </a:solidFill>
+          </a:ln>
+        </p:spPr>
+        <p:style>
+          <a:lnRef idx="1">
+            <a:schemeClr val="accent1"/>
+          </a:lnRef>
+          <a:fillRef idx="3">
+            <a:schemeClr val="accent1"/>
+          </a:fillRef>
+          <a:effectRef idx="2">
+            <a:schemeClr val="accent1"/>
+          </a:effectRef>
+          <a:fontRef idx="minor">
+            <a:schemeClr val="lt1"/>
+          </a:fontRef>
+        </p:style>
+        <p:txBody>
+          <a:bodyPr rtlCol="0" anchor="ctr"/>
+          <a:lstStyle/>
+          <a:p>
+            <a:pPr algn="ctr">
+              <a:defRPr sz="850" b="1">
+                <a:solidFill>
+                  <a:srgbClr val="2A9D8F"/>
+                </a:solidFill>
+              </a:defRPr>
+            </a:pPr>
+            <a:r>
+              <a:t>+10.1%</a:t>
+            </a:r>
+          </a:p>
+        </p:txBody>
+      </p:sp>
+      <p:sp>
+        <p:nvSpPr>
+          <p:cNvPr id="35" name="Rectangle 34"/>
+          <p:cNvSpPr/>
+          <p:nvPr/>
+        </p:nvSpPr>
+        <p:spPr>
+          <a:xfrm>
+            <a:off x="6217920" y="2194560"/>
+            <a:ext cx="1554480" cy="274320"/>
+          </a:xfrm>
+          <a:prstGeom prst="rect">
+            <a:avLst/>
+          </a:prstGeom>
+          <a:solidFill>
+            <a:srgbClr val="FFFFFF"/>
+          </a:solidFill>
+          <a:ln w="6350">
+            <a:solidFill>
+              <a:srgbClr val="959595"/>
+            </a:solidFill>
+          </a:ln>
+        </p:spPr>
+        <p:style>
+          <a:lnRef idx="1">
+            <a:schemeClr val="accent1"/>
+          </a:lnRef>
+          <a:fillRef idx="3">
+            <a:schemeClr val="accent1"/>
+          </a:fillRef>
+          <a:effectRef idx="2">
+            <a:schemeClr val="accent1"/>
+          </a:effectRef>
+          <a:fontRef idx="minor">
+            <a:schemeClr val="lt1"/>
+          </a:fontRef>
+        </p:style>
+        <p:txBody>
+          <a:bodyPr rtlCol="0" anchor="ctr"/>
+          <a:lstStyle/>
+          <a:p>
+            <a:pPr algn="ctr">
+              <a:defRPr sz="850"/>
+            </a:pPr>
+            <a:r>
+              <a:t>22-Aug</a:t>
+            </a:r>
+          </a:p>
+        </p:txBody>
+      </p:sp>
+      <p:sp>
+        <p:nvSpPr>
+          <p:cNvPr id="36" name="Rectangle 35"/>
+          <p:cNvSpPr/>
+          <p:nvPr/>
+        </p:nvSpPr>
+        <p:spPr>
+          <a:xfrm>
+            <a:off x="457200" y="2468880"/>
+            <a:ext cx="8229600" cy="274320"/>
+          </a:xfrm>
+          <a:prstGeom prst="rect">
+            <a:avLst/>
+          </a:prstGeom>
+          <a:solidFill>
+            <a:srgbClr val="F5F5F5"/>
+          </a:solidFill>
+          <a:ln/>
+        </p:spPr>
+        <p:style>
+          <a:lnRef idx="1">
+            <a:schemeClr val="accent1"/>
+          </a:lnRef>
+          <a:fillRef idx="3">
+            <a:schemeClr val="accent1"/>
+          </a:fillRef>
+          <a:effectRef idx="2">
+            <a:schemeClr val="accent1"/>
+          </a:effectRef>
+          <a:fontRef idx="minor">
+            <a:schemeClr val="lt1"/>
+          </a:fontRef>
+        </p:style>
+        <p:txBody>
+          <a:bodyPr rtlCol="0" anchor="ctr"/>
+          <a:lstStyle/>
+          <a:p>
+            <a:pPr algn="ctr"/>
+          </a:p>
+        </p:txBody>
+      </p:sp>
+      <p:sp>
+        <p:nvSpPr>
+          <p:cNvPr id="37" name="Rectangle 36"/>
+          <p:cNvSpPr/>
+          <p:nvPr/>
+        </p:nvSpPr>
+        <p:spPr>
+          <a:xfrm>
+            <a:off x="457200" y="2468880"/>
+            <a:ext cx="1005840" cy="274320"/>
+          </a:xfrm>
+          <a:prstGeom prst="rect">
+            <a:avLst/>
+          </a:prstGeom>
+          <a:solidFill>
+            <a:srgbClr val="FFFFFF"/>
+          </a:solidFill>
+          <a:ln w="6350">
+            <a:solidFill>
+              <a:srgbClr val="959595"/>
+            </a:solidFill>
+          </a:ln>
+        </p:spPr>
+        <p:style>
+          <a:lnRef idx="1">
+            <a:schemeClr val="accent1"/>
+          </a:lnRef>
+          <a:fillRef idx="3">
+            <a:schemeClr val="accent1"/>
+          </a:fillRef>
+          <a:effectRef idx="2">
+            <a:schemeClr val="accent1"/>
+          </a:effectRef>
+          <a:fontRef idx="minor">
+            <a:schemeClr val="lt1"/>
+          </a:fontRef>
+        </p:style>
+        <p:txBody>
+          <a:bodyPr rtlCol="0" anchor="ctr"/>
+          <a:lstStyle/>
+          <a:p>
+            <a:pPr algn="ctr">
+              <a:defRPr sz="850" b="1">
+                <a:solidFill>
+                  <a:srgbClr val="7B2CBA"/>
+                </a:solidFill>
+              </a:defRPr>
+            </a:pPr>
+            <a:r>
+              <a:t>RKAM</a:t>
+            </a:r>
+          </a:p>
+        </p:txBody>
+      </p:sp>
+      <p:sp>
+        <p:nvSpPr>
+          <p:cNvPr id="38" name="Rectangle 37"/>
+          <p:cNvSpPr/>
+          <p:nvPr/>
+        </p:nvSpPr>
+        <p:spPr>
+          <a:xfrm>
+            <a:off x="1463040" y="2468880"/>
+            <a:ext cx="1188720" cy="274320"/>
+          </a:xfrm>
+          <a:prstGeom prst="rect">
+            <a:avLst/>
+          </a:prstGeom>
+          <a:solidFill>
+            <a:srgbClr val="FFFFFF"/>
+          </a:solidFill>
+          <a:ln w="6350">
+            <a:solidFill>
+              <a:srgbClr val="959595"/>
+            </a:solidFill>
+          </a:ln>
+        </p:spPr>
+        <p:style>
+          <a:lnRef idx="1">
+            <a:schemeClr val="accent1"/>
+          </a:lnRef>
+          <a:fillRef idx="3">
+            <a:schemeClr val="accent1"/>
+          </a:fillRef>
+          <a:effectRef idx="2">
+            <a:schemeClr val="accent1"/>
+          </a:effectRef>
+          <a:fontRef idx="minor">
+            <a:schemeClr val="lt1"/>
+          </a:fontRef>
+        </p:style>
+        <p:txBody>
+          <a:bodyPr rtlCol="0" anchor="ctr"/>
+          <a:lstStyle/>
+          <a:p>
+            <a:pPr algn="l">
+              <a:defRPr sz="850"/>
+            </a:pPr>
+            <a:r>
+              <a:t>Central Region</a:t>
+            </a:r>
+          </a:p>
+        </p:txBody>
+      </p:sp>
+      <p:sp>
+        <p:nvSpPr>
+          <p:cNvPr id="39" name="Rectangle 38"/>
+          <p:cNvSpPr/>
+          <p:nvPr/>
+        </p:nvSpPr>
+        <p:spPr>
+          <a:xfrm>
+            <a:off x="2651760" y="2468880"/>
+            <a:ext cx="1188720" cy="274320"/>
+          </a:xfrm>
+          <a:prstGeom prst="rect">
+            <a:avLst/>
+          </a:prstGeom>
+          <a:solidFill>
+            <a:srgbClr val="FFFFFF"/>
+          </a:solidFill>
+          <a:ln w="6350">
+            <a:solidFill>
+              <a:srgbClr val="959595"/>
+            </a:solidFill>
+          </a:ln>
+        </p:spPr>
+        <p:style>
+          <a:lnRef idx="1">
+            <a:schemeClr val="accent1"/>
+          </a:lnRef>
+          <a:fillRef idx="3">
+            <a:schemeClr val="accent1"/>
+          </a:fillRef>
+          <a:effectRef idx="2">
+            <a:schemeClr val="accent1"/>
+          </a:effectRef>
+          <a:fontRef idx="minor">
+            <a:schemeClr val="lt1"/>
+          </a:fontRef>
+        </p:style>
+        <p:txBody>
+          <a:bodyPr rtlCol="0" anchor="ctr"/>
+          <a:lstStyle/>
+          <a:p>
+            <a:pPr algn="ctr">
+              <a:defRPr sz="850"/>
+            </a:pPr>
+            <a:r>
+              <a:t>₹6.1 Cr</a:t>
+            </a:r>
+          </a:p>
+        </p:txBody>
+      </p:sp>
+      <p:sp>
+        <p:nvSpPr>
+          <p:cNvPr id="40" name="Rectangle 39"/>
+          <p:cNvSpPr/>
+          <p:nvPr/>
+        </p:nvSpPr>
+        <p:spPr>
+          <a:xfrm>
+            <a:off x="3840480" y="2468880"/>
+            <a:ext cx="1280160" cy="274320"/>
+          </a:xfrm>
+          <a:prstGeom prst="rect">
+            <a:avLst/>
+          </a:prstGeom>
+          <a:solidFill>
+            <a:srgbClr val="FFFFFF"/>
+          </a:solidFill>
+          <a:ln w="6350">
+            <a:solidFill>
+              <a:srgbClr val="959595"/>
+            </a:solidFill>
+          </a:ln>
+        </p:spPr>
+        <p:style>
+          <a:lnRef idx="1">
+            <a:schemeClr val="accent1"/>
+          </a:lnRef>
+          <a:fillRef idx="3">
+            <a:schemeClr val="accent1"/>
+          </a:fillRef>
+          <a:effectRef idx="2">
+            <a:schemeClr val="accent1"/>
+          </a:effectRef>
+          <a:fontRef idx="minor">
+            <a:schemeClr val="lt1"/>
+          </a:fontRef>
+        </p:style>
+        <p:txBody>
+          <a:bodyPr rtlCol="0" anchor="ctr"/>
+          <a:lstStyle/>
+          <a:p>
+            <a:pPr algn="ctr">
+              <a:defRPr sz="850"/>
+            </a:pPr>
+            <a:r>
+              <a:t>₹6.9 Cr</a:t>
+            </a:r>
+          </a:p>
+        </p:txBody>
+      </p:sp>
+      <p:sp>
+        <p:nvSpPr>
+          <p:cNvPr id="41" name="Rectangle 40"/>
+          <p:cNvSpPr/>
+          <p:nvPr/>
+        </p:nvSpPr>
+        <p:spPr>
+          <a:xfrm>
+            <a:off x="5120640" y="2468880"/>
+            <a:ext cx="1097280" cy="274320"/>
+          </a:xfrm>
+          <a:prstGeom prst="rect">
+            <a:avLst/>
+          </a:prstGeom>
+          <a:solidFill>
+            <a:srgbClr val="FFFFFF"/>
+          </a:solidFill>
+          <a:ln w="6350">
+            <a:solidFill>
+              <a:srgbClr val="959595"/>
+            </a:solidFill>
+          </a:ln>
+        </p:spPr>
+        <p:style>
+          <a:lnRef idx="1">
+            <a:schemeClr val="accent1"/>
+          </a:lnRef>
+          <a:fillRef idx="3">
+            <a:schemeClr val="accent1"/>
+          </a:fillRef>
+          <a:effectRef idx="2">
+            <a:schemeClr val="accent1"/>
+          </a:effectRef>
+          <a:fontRef idx="minor">
+            <a:schemeClr val="lt1"/>
+          </a:fontRef>
+        </p:style>
+        <p:txBody>
+          <a:bodyPr rtlCol="0" anchor="ctr"/>
+          <a:lstStyle/>
+          <a:p>
+            <a:pPr algn="ctr">
+              <a:defRPr sz="850" b="1">
+                <a:solidFill>
+                  <a:srgbClr val="2A9D8F"/>
+                </a:solidFill>
+              </a:defRPr>
+            </a:pPr>
+            <a:r>
+              <a:t>+13.1%</a:t>
+            </a:r>
+          </a:p>
+        </p:txBody>
+      </p:sp>
+      <p:sp>
+        <p:nvSpPr>
+          <p:cNvPr id="42" name="Rectangle 41"/>
+          <p:cNvSpPr/>
+          <p:nvPr/>
+        </p:nvSpPr>
+        <p:spPr>
+          <a:xfrm>
+            <a:off x="6217920" y="2468880"/>
+            <a:ext cx="1554480" cy="274320"/>
+          </a:xfrm>
+          <a:prstGeom prst="rect">
+            <a:avLst/>
+          </a:prstGeom>
+          <a:solidFill>
+            <a:srgbClr val="FFFFFF"/>
+          </a:solidFill>
+          <a:ln w="6350">
+            <a:solidFill>
+              <a:srgbClr val="959595"/>
+            </a:solidFill>
+          </a:ln>
+        </p:spPr>
+        <p:style>
+          <a:lnRef idx="1">
+            <a:schemeClr val="accent1"/>
+          </a:lnRef>
+          <a:fillRef idx="3">
+            <a:schemeClr val="accent1"/>
+          </a:fillRef>
+          <a:effectRef idx="2">
+            <a:schemeClr val="accent1"/>
+          </a:effectRef>
+          <a:fontRef idx="minor">
+            <a:schemeClr val="lt1"/>
+          </a:fontRef>
+        </p:style>
+        <p:txBody>
+          <a:bodyPr rtlCol="0" anchor="ctr"/>
+          <a:lstStyle/>
+          <a:p>
+            <a:pPr algn="ctr">
+              <a:defRPr sz="850"/>
+            </a:pPr>
+            <a:r>
+              <a:t>28-Aug</a:t>
+            </a:r>
+          </a:p>
+        </p:txBody>
+      </p:sp>
+      <p:sp>
+        <p:nvSpPr>
+          <p:cNvPr id="43" name="Rectangle 42"/>
+          <p:cNvSpPr/>
+          <p:nvPr/>
+        </p:nvSpPr>
+        <p:spPr>
+          <a:xfrm>
+            <a:off x="457200" y="2743200"/>
+            <a:ext cx="1005840" cy="274320"/>
+          </a:xfrm>
+          <a:prstGeom prst="rect">
+            <a:avLst/>
+          </a:prstGeom>
+          <a:solidFill>
+            <a:srgbClr val="FFFFFF"/>
+          </a:solidFill>
+          <a:ln w="6350">
+            <a:solidFill>
+              <a:srgbClr val="959595"/>
+            </a:solidFill>
+          </a:ln>
+        </p:spPr>
+        <p:style>
+          <a:lnRef idx="1">
+            <a:schemeClr val="accent1"/>
+          </a:lnRef>
+          <a:fillRef idx="3">
+            <a:schemeClr val="accent1"/>
+          </a:fillRef>
+          <a:effectRef idx="2">
+            <a:schemeClr val="accent1"/>
+          </a:effectRef>
+          <a:fontRef idx="minor">
+            <a:schemeClr val="lt1"/>
+          </a:fontRef>
+        </p:style>
+        <p:txBody>
+          <a:bodyPr rtlCol="0" anchor="ctr"/>
+          <a:lstStyle/>
+          <a:p>
+            <a:pPr algn="ctr">
+              <a:defRPr sz="850" b="1">
+                <a:solidFill>
+                  <a:srgbClr val="006EE6"/>
+                </a:solidFill>
+              </a:defRPr>
+            </a:pPr>
+            <a:r>
+              <a:t>NKAM</a:t>
+            </a:r>
+          </a:p>
+        </p:txBody>
+      </p:sp>
+      <p:sp>
+        <p:nvSpPr>
+          <p:cNvPr id="44" name="Rectangle 43"/>
+          <p:cNvSpPr/>
+          <p:nvPr/>
+        </p:nvSpPr>
+        <p:spPr>
+          <a:xfrm>
+            <a:off x="1463040" y="2743200"/>
+            <a:ext cx="1188720" cy="274320"/>
+          </a:xfrm>
+          <a:prstGeom prst="rect">
+            <a:avLst/>
+          </a:prstGeom>
+          <a:solidFill>
+            <a:srgbClr val="FFFFFF"/>
+          </a:solidFill>
+          <a:ln w="6350">
+            <a:solidFill>
+              <a:srgbClr val="959595"/>
+            </a:solidFill>
+          </a:ln>
+        </p:spPr>
+        <p:style>
+          <a:lnRef idx="1">
+            <a:schemeClr val="accent1"/>
+          </a:lnRef>
+          <a:fillRef idx="3">
+            <a:schemeClr val="accent1"/>
+          </a:fillRef>
+          <a:effectRef idx="2">
+            <a:schemeClr val="accent1"/>
+          </a:effectRef>
+          <a:fontRef idx="minor">
+            <a:schemeClr val="lt1"/>
+          </a:fontRef>
+        </p:style>
+        <p:txBody>
+          <a:bodyPr rtlCol="0" anchor="ctr"/>
+          <a:lstStyle/>
+          <a:p>
+            <a:pPr algn="l">
+              <a:defRPr sz="850"/>
+            </a:pPr>
+            <a:r>
+              <a:t>Apollo</a:t>
+            </a:r>
+          </a:p>
+        </p:txBody>
+      </p:sp>
+      <p:sp>
+        <p:nvSpPr>
+          <p:cNvPr id="45" name="Rectangle 44"/>
+          <p:cNvSpPr/>
+          <p:nvPr/>
+        </p:nvSpPr>
+        <p:spPr>
+          <a:xfrm>
+            <a:off x="2651760" y="2743200"/>
+            <a:ext cx="1188720" cy="274320"/>
+          </a:xfrm>
+          <a:prstGeom prst="rect">
+            <a:avLst/>
+          </a:prstGeom>
+          <a:solidFill>
+            <a:srgbClr val="FFFFFF"/>
+          </a:solidFill>
+          <a:ln w="6350">
+            <a:solidFill>
+              <a:srgbClr val="959595"/>
+            </a:solidFill>
+          </a:ln>
+        </p:spPr>
+        <p:style>
+          <a:lnRef idx="1">
+            <a:schemeClr val="accent1"/>
+          </a:lnRef>
+          <a:fillRef idx="3">
+            <a:schemeClr val="accent1"/>
+          </a:fillRef>
+          <a:effectRef idx="2">
+            <a:schemeClr val="accent1"/>
+          </a:effectRef>
+          <a:fontRef idx="minor">
+            <a:schemeClr val="lt1"/>
+          </a:fontRef>
+        </p:style>
+        <p:txBody>
+          <a:bodyPr rtlCol="0" anchor="ctr"/>
+          <a:lstStyle/>
+          <a:p>
+            <a:pPr algn="ctr">
+              <a:defRPr sz="850"/>
+            </a:pPr>
+            <a:r>
+              <a:t>₹28.9 Cr</a:t>
+            </a:r>
+          </a:p>
+        </p:txBody>
+      </p:sp>
+      <p:sp>
+        <p:nvSpPr>
+          <p:cNvPr id="46" name="Rectangle 45"/>
+          <p:cNvSpPr/>
+          <p:nvPr/>
+        </p:nvSpPr>
+        <p:spPr>
+          <a:xfrm>
+            <a:off x="3840480" y="2743200"/>
+            <a:ext cx="1280160" cy="274320"/>
+          </a:xfrm>
+          <a:prstGeom prst="rect">
+            <a:avLst/>
+          </a:prstGeom>
+          <a:solidFill>
+            <a:srgbClr val="FFFFFF"/>
+          </a:solidFill>
+          <a:ln w="6350">
+            <a:solidFill>
+              <a:srgbClr val="959595"/>
+            </a:solidFill>
+          </a:ln>
+        </p:spPr>
+        <p:style>
+          <a:lnRef idx="1">
+            <a:schemeClr val="accent1"/>
+          </a:lnRef>
+          <a:fillRef idx="3">
+            <a:schemeClr val="accent1"/>
+          </a:fillRef>
+          <a:effectRef idx="2">
+            <a:schemeClr val="accent1"/>
+          </a:effectRef>
+          <a:fontRef idx="minor">
+            <a:schemeClr val="lt1"/>
+          </a:fontRef>
+        </p:style>
+        <p:txBody>
+          <a:bodyPr rtlCol="0" anchor="ctr"/>
+          <a:lstStyle/>
+          <a:p>
+            <a:pPr algn="ctr">
+              <a:defRPr sz="850"/>
+            </a:pPr>
+            <a:r>
+              <a:t>₹32.4 Cr</a:t>
+            </a:r>
+          </a:p>
+        </p:txBody>
+      </p:sp>
+      <p:sp>
+        <p:nvSpPr>
+          <p:cNvPr id="47" name="Rectangle 46"/>
+          <p:cNvSpPr/>
+          <p:nvPr/>
+        </p:nvSpPr>
+        <p:spPr>
+          <a:xfrm>
+            <a:off x="5120640" y="2743200"/>
+            <a:ext cx="1097280" cy="274320"/>
+          </a:xfrm>
+          <a:prstGeom prst="rect">
+            <a:avLst/>
+          </a:prstGeom>
+          <a:solidFill>
+            <a:srgbClr val="FFFFFF"/>
+          </a:solidFill>
+          <a:ln w="6350">
+            <a:solidFill>
+              <a:srgbClr val="959595"/>
+            </a:solidFill>
+          </a:ln>
+        </p:spPr>
+        <p:style>
+          <a:lnRef idx="1">
+            <a:schemeClr val="accent1"/>
+          </a:lnRef>
+          <a:fillRef idx="3">
+            <a:schemeClr val="accent1"/>
+          </a:fillRef>
+          <a:effectRef idx="2">
+            <a:schemeClr val="accent1"/>
+          </a:effectRef>
+          <a:fontRef idx="minor">
+            <a:schemeClr val="lt1"/>
+          </a:fontRef>
+        </p:style>
+        <p:txBody>
+          <a:bodyPr rtlCol="0" anchor="ctr"/>
+          <a:lstStyle/>
+          <a:p>
+            <a:pPr algn="ctr">
+              <a:defRPr sz="850" b="1">
+                <a:solidFill>
+                  <a:srgbClr val="2A9D8F"/>
+                </a:solidFill>
+              </a:defRPr>
+            </a:pPr>
+            <a:r>
+              <a:t>+12.1%</a:t>
+            </a:r>
+          </a:p>
+        </p:txBody>
+      </p:sp>
+      <p:sp>
+        <p:nvSpPr>
+          <p:cNvPr id="48" name="Rectangle 47"/>
+          <p:cNvSpPr/>
+          <p:nvPr/>
+        </p:nvSpPr>
+        <p:spPr>
+          <a:xfrm>
+            <a:off x="6217920" y="2743200"/>
+            <a:ext cx="1554480" cy="274320"/>
+          </a:xfrm>
+          <a:prstGeom prst="rect">
+            <a:avLst/>
+          </a:prstGeom>
+          <a:solidFill>
+            <a:srgbClr val="FFFFFF"/>
+          </a:solidFill>
+          <a:ln w="6350">
+            <a:solidFill>
+              <a:srgbClr val="959595"/>
+            </a:solidFill>
+          </a:ln>
+        </p:spPr>
+        <p:style>
+          <a:lnRef idx="1">
+            <a:schemeClr val="accent1"/>
+          </a:lnRef>
+          <a:fillRef idx="3">
+            <a:schemeClr val="accent1"/>
+          </a:fillRef>
+          <a:effectRef idx="2">
+            <a:schemeClr val="accent1"/>
+          </a:effectRef>
+          <a:fontRef idx="minor">
+            <a:schemeClr val="lt1"/>
+          </a:fontRef>
+        </p:style>
+        <p:txBody>
+          <a:bodyPr rtlCol="0" anchor="ctr"/>
+          <a:lstStyle/>
+          <a:p>
+            <a:pPr algn="ctr">
+              <a:defRPr sz="850"/>
+            </a:pPr>
+            <a:r>
+              <a:t>20-Aug</a:t>
+            </a:r>
+          </a:p>
+        </p:txBody>
+      </p:sp>
+      <p:sp>
+        <p:nvSpPr>
+          <p:cNvPr id="49" name="Rectangle 48"/>
+          <p:cNvSpPr/>
+          <p:nvPr/>
+        </p:nvSpPr>
+        <p:spPr>
+          <a:xfrm>
+            <a:off x="457200" y="3017520"/>
+            <a:ext cx="8229600" cy="274320"/>
+          </a:xfrm>
+          <a:prstGeom prst="rect">
+            <a:avLst/>
+          </a:prstGeom>
+          <a:solidFill>
+            <a:srgbClr val="F5F5F5"/>
+          </a:solidFill>
+          <a:ln/>
+        </p:spPr>
+        <p:style>
+          <a:lnRef idx="1">
+            <a:schemeClr val="accent1"/>
+          </a:lnRef>
+          <a:fillRef idx="3">
+            <a:schemeClr val="accent1"/>
+          </a:fillRef>
+          <a:effectRef idx="2">
+            <a:schemeClr val="accent1"/>
+          </a:effectRef>
+          <a:fontRef idx="minor">
+            <a:schemeClr val="lt1"/>
+          </a:fontRef>
+        </p:style>
+        <p:txBody>
+          <a:bodyPr rtlCol="0" anchor="ctr"/>
+          <a:lstStyle/>
+          <a:p>
+            <a:pPr algn="ctr"/>
+          </a:p>
+        </p:txBody>
+      </p:sp>
+      <p:sp>
+        <p:nvSpPr>
+          <p:cNvPr id="50" name="Rectangle 49"/>
+          <p:cNvSpPr/>
+          <p:nvPr/>
+        </p:nvSpPr>
+        <p:spPr>
+          <a:xfrm>
+            <a:off x="457200" y="3017520"/>
+            <a:ext cx="1005840" cy="274320"/>
+          </a:xfrm>
+          <a:prstGeom prst="rect">
+            <a:avLst/>
+          </a:prstGeom>
+          <a:solidFill>
+            <a:srgbClr val="FFFFFF"/>
+          </a:solidFill>
+          <a:ln w="6350">
+            <a:solidFill>
+              <a:srgbClr val="959595"/>
+            </a:solidFill>
+          </a:ln>
+        </p:spPr>
+        <p:style>
+          <a:lnRef idx="1">
+            <a:schemeClr val="accent1"/>
+          </a:lnRef>
+          <a:fillRef idx="3">
+            <a:schemeClr val="accent1"/>
+          </a:fillRef>
+          <a:effectRef idx="2">
+            <a:schemeClr val="accent1"/>
+          </a:effectRef>
+          <a:fontRef idx="minor">
+            <a:schemeClr val="lt1"/>
+          </a:fontRef>
+        </p:style>
+        <p:txBody>
+          <a:bodyPr rtlCol="0" anchor="ctr"/>
+          <a:lstStyle/>
+          <a:p>
+            <a:pPr algn="ctr">
+              <a:defRPr sz="850" b="1">
+                <a:solidFill>
+                  <a:srgbClr val="006EE6"/>
+                </a:solidFill>
+              </a:defRPr>
+            </a:pPr>
+            <a:r>
+              <a:t>NKAM</a:t>
+            </a:r>
+          </a:p>
+        </p:txBody>
+      </p:sp>
+      <p:sp>
+        <p:nvSpPr>
+          <p:cNvPr id="51" name="Rectangle 50"/>
+          <p:cNvSpPr/>
+          <p:nvPr/>
+        </p:nvSpPr>
+        <p:spPr>
+          <a:xfrm>
+            <a:off x="1463040" y="3017520"/>
+            <a:ext cx="1188720" cy="274320"/>
+          </a:xfrm>
+          <a:prstGeom prst="rect">
+            <a:avLst/>
+          </a:prstGeom>
+          <a:solidFill>
+            <a:srgbClr val="FFFFFF"/>
+          </a:solidFill>
+          <a:ln w="6350">
+            <a:solidFill>
+              <a:srgbClr val="959595"/>
+            </a:solidFill>
+          </a:ln>
+        </p:spPr>
+        <p:style>
+          <a:lnRef idx="1">
+            <a:schemeClr val="accent1"/>
+          </a:lnRef>
+          <a:fillRef idx="3">
+            <a:schemeClr val="accent1"/>
+          </a:fillRef>
+          <a:effectRef idx="2">
+            <a:schemeClr val="accent1"/>
+          </a:effectRef>
+          <a:fontRef idx="minor">
+            <a:schemeClr val="lt1"/>
+          </a:fontRef>
+        </p:style>
+        <p:txBody>
+          <a:bodyPr rtlCol="0" anchor="ctr"/>
+          <a:lstStyle/>
+          <a:p>
+            <a:pPr algn="l">
+              <a:defRPr sz="850"/>
+            </a:pPr>
+            <a:r>
+              <a:t>Reliance Retail</a:t>
+            </a:r>
+          </a:p>
+        </p:txBody>
+      </p:sp>
+      <p:sp>
+        <p:nvSpPr>
+          <p:cNvPr id="52" name="Rectangle 51"/>
+          <p:cNvSpPr/>
+          <p:nvPr/>
+        </p:nvSpPr>
+        <p:spPr>
+          <a:xfrm>
+            <a:off x="2651760" y="3017520"/>
+            <a:ext cx="1188720" cy="274320"/>
+          </a:xfrm>
+          <a:prstGeom prst="rect">
+            <a:avLst/>
+          </a:prstGeom>
+          <a:solidFill>
+            <a:srgbClr val="FFFFFF"/>
+          </a:solidFill>
+          <a:ln w="6350">
+            <a:solidFill>
+              <a:srgbClr val="959595"/>
+            </a:solidFill>
+          </a:ln>
+        </p:spPr>
+        <p:style>
+          <a:lnRef idx="1">
+            <a:schemeClr val="accent1"/>
+          </a:lnRef>
+          <a:fillRef idx="3">
+            <a:schemeClr val="accent1"/>
+          </a:fillRef>
+          <a:effectRef idx="2">
+            <a:schemeClr val="accent1"/>
+          </a:effectRef>
+          <a:fontRef idx="minor">
+            <a:schemeClr val="lt1"/>
+          </a:fontRef>
+        </p:style>
+        <p:txBody>
+          <a:bodyPr rtlCol="0" anchor="ctr"/>
+          <a:lstStyle/>
+          <a:p>
+            <a:pPr algn="ctr">
+              <a:defRPr sz="850"/>
+            </a:pPr>
+            <a:r>
+              <a:t>₹24.4 Cr</a:t>
+            </a:r>
+          </a:p>
+        </p:txBody>
+      </p:sp>
+      <p:sp>
+        <p:nvSpPr>
+          <p:cNvPr id="53" name="Rectangle 52"/>
+          <p:cNvSpPr/>
+          <p:nvPr/>
+        </p:nvSpPr>
+        <p:spPr>
+          <a:xfrm>
+            <a:off x="3840480" y="3017520"/>
+            <a:ext cx="1280160" cy="274320"/>
+          </a:xfrm>
+          <a:prstGeom prst="rect">
+            <a:avLst/>
+          </a:prstGeom>
+          <a:solidFill>
+            <a:srgbClr val="FFFFFF"/>
+          </a:solidFill>
+          <a:ln w="6350">
+            <a:solidFill>
+              <a:srgbClr val="959595"/>
+            </a:solidFill>
+          </a:ln>
+        </p:spPr>
+        <p:style>
+          <a:lnRef idx="1">
+            <a:schemeClr val="accent1"/>
+          </a:lnRef>
+          <a:fillRef idx="3">
+            <a:schemeClr val="accent1"/>
+          </a:fillRef>
+          <a:effectRef idx="2">
+            <a:schemeClr val="accent1"/>
+          </a:effectRef>
+          <a:fontRef idx="minor">
+            <a:schemeClr val="lt1"/>
+          </a:fontRef>
+        </p:style>
+        <p:txBody>
+          <a:bodyPr rtlCol="0" anchor="ctr"/>
+          <a:lstStyle/>
+          <a:p>
+            <a:pPr algn="ctr">
+              <a:defRPr sz="850"/>
+            </a:pPr>
+            <a:r>
+              <a:t>₹28.1 Cr</a:t>
+            </a:r>
+          </a:p>
+        </p:txBody>
+      </p:sp>
+      <p:sp>
+        <p:nvSpPr>
+          <p:cNvPr id="54" name="Rectangle 53"/>
+          <p:cNvSpPr/>
+          <p:nvPr/>
+        </p:nvSpPr>
+        <p:spPr>
+          <a:xfrm>
+            <a:off x="5120640" y="3017520"/>
+            <a:ext cx="1097280" cy="274320"/>
+          </a:xfrm>
+          <a:prstGeom prst="rect">
+            <a:avLst/>
+          </a:prstGeom>
+          <a:solidFill>
+            <a:srgbClr val="FFFFFF"/>
+          </a:solidFill>
+          <a:ln w="6350">
+            <a:solidFill>
+              <a:srgbClr val="959595"/>
+            </a:solidFill>
+          </a:ln>
+        </p:spPr>
+        <p:style>
+          <a:lnRef idx="1">
+            <a:schemeClr val="accent1"/>
+          </a:lnRef>
+          <a:fillRef idx="3">
+            <a:schemeClr val="accent1"/>
+          </a:fillRef>
+          <a:effectRef idx="2">
+            <a:schemeClr val="accent1"/>
+          </a:effectRef>
+          <a:fontRef idx="minor">
+            <a:schemeClr val="lt1"/>
+          </a:fontRef>
+        </p:style>
+        <p:txBody>
+          <a:bodyPr rtlCol="0" anchor="ctr"/>
+          <a:lstStyle/>
+          <a:p>
+            <a:pPr algn="ctr">
+              <a:defRPr sz="850" b="1">
+                <a:solidFill>
+                  <a:srgbClr val="2A9D8F"/>
+                </a:solidFill>
+              </a:defRPr>
+            </a:pPr>
+            <a:r>
+              <a:t>+15.2%</a:t>
+            </a:r>
+          </a:p>
+        </p:txBody>
+      </p:sp>
+      <p:sp>
+        <p:nvSpPr>
+          <p:cNvPr id="55" name="Rectangle 54"/>
+          <p:cNvSpPr/>
+          <p:nvPr/>
+        </p:nvSpPr>
+        <p:spPr>
+          <a:xfrm>
+            <a:off x="6217920" y="3017520"/>
+            <a:ext cx="1554480" cy="274320"/>
+          </a:xfrm>
+          <a:prstGeom prst="rect">
+            <a:avLst/>
+          </a:prstGeom>
+          <a:solidFill>
+            <a:srgbClr val="FFFFFF"/>
+          </a:solidFill>
+          <a:ln w="6350">
+            <a:solidFill>
+              <a:srgbClr val="959595"/>
+            </a:solidFill>
+          </a:ln>
+        </p:spPr>
+        <p:style>
+          <a:lnRef idx="1">
+            <a:schemeClr val="accent1"/>
+          </a:lnRef>
+          <a:fillRef idx="3">
+            <a:schemeClr val="accent1"/>
+          </a:fillRef>
+          <a:effectRef idx="2">
+            <a:schemeClr val="accent1"/>
+          </a:effectRef>
+          <a:fontRef idx="minor">
+            <a:schemeClr val="lt1"/>
+          </a:fontRef>
+        </p:style>
+        <p:txBody>
+          <a:bodyPr rtlCol="0" anchor="ctr"/>
+          <a:lstStyle/>
+          <a:p>
+            <a:pPr algn="ctr">
+              <a:defRPr sz="850"/>
+            </a:pPr>
+            <a:r>
+              <a:t>22-Aug</a:t>
+            </a:r>
+          </a:p>
+        </p:txBody>
+      </p:sp>
+      <p:sp>
+        <p:nvSpPr>
+          <p:cNvPr id="56" name="Rectangle 55"/>
+          <p:cNvSpPr/>
+          <p:nvPr/>
+        </p:nvSpPr>
+        <p:spPr>
+          <a:xfrm>
+            <a:off x="457200" y="3291840"/>
+            <a:ext cx="1005840" cy="274320"/>
+          </a:xfrm>
+          <a:prstGeom prst="rect">
+            <a:avLst/>
+          </a:prstGeom>
+          <a:solidFill>
+            <a:srgbClr val="FFFFFF"/>
+          </a:solidFill>
+          <a:ln w="6350">
+            <a:solidFill>
+              <a:srgbClr val="959595"/>
+            </a:solidFill>
+          </a:ln>
+        </p:spPr>
+        <p:style>
+          <a:lnRef idx="1">
+            <a:schemeClr val="accent1"/>
+          </a:lnRef>
+          <a:fillRef idx="3">
+            <a:schemeClr val="accent1"/>
+          </a:fillRef>
+          <a:effectRef idx="2">
+            <a:schemeClr val="accent1"/>
+          </a:effectRef>
+          <a:fontRef idx="minor">
+            <a:schemeClr val="lt1"/>
+          </a:fontRef>
+        </p:style>
+        <p:txBody>
+          <a:bodyPr rtlCol="0" anchor="ctr"/>
+          <a:lstStyle/>
+          <a:p>
+            <a:pPr algn="ctr">
+              <a:defRPr sz="850" b="1">
+                <a:solidFill>
+                  <a:srgbClr val="006EE6"/>
+                </a:solidFill>
+              </a:defRPr>
+            </a:pPr>
+            <a:r>
+              <a:t>NKAM</a:t>
+            </a:r>
+          </a:p>
+        </p:txBody>
+      </p:sp>
+      <p:sp>
+        <p:nvSpPr>
+          <p:cNvPr id="57" name="Rectangle 56"/>
+          <p:cNvSpPr/>
+          <p:nvPr/>
+        </p:nvSpPr>
+        <p:spPr>
+          <a:xfrm>
+            <a:off x="1463040" y="3291840"/>
+            <a:ext cx="1188720" cy="274320"/>
+          </a:xfrm>
+          <a:prstGeom prst="rect">
+            <a:avLst/>
+          </a:prstGeom>
+          <a:solidFill>
+            <a:srgbClr val="FFFFFF"/>
+          </a:solidFill>
+          <a:ln w="6350">
+            <a:solidFill>
+              <a:srgbClr val="959595"/>
+            </a:solidFill>
+          </a:ln>
+        </p:spPr>
+        <p:style>
+          <a:lnRef idx="1">
+            <a:schemeClr val="accent1"/>
+          </a:lnRef>
+          <a:fillRef idx="3">
+            <a:schemeClr val="accent1"/>
+          </a:fillRef>
+          <a:effectRef idx="2">
+            <a:schemeClr val="accent1"/>
+          </a:effectRef>
+          <a:fontRef idx="minor">
+            <a:schemeClr val="lt1"/>
+          </a:fontRef>
+        </p:style>
+        <p:txBody>
+          <a:bodyPr rtlCol="0" anchor="ctr"/>
+          <a:lstStyle/>
+          <a:p>
+            <a:pPr algn="l">
+              <a:defRPr sz="850"/>
+            </a:pPr>
+            <a:r>
+              <a:t>D-Mart</a:t>
+            </a:r>
+          </a:p>
+        </p:txBody>
+      </p:sp>
+      <p:sp>
+        <p:nvSpPr>
+          <p:cNvPr id="58" name="Rectangle 57"/>
+          <p:cNvSpPr/>
+          <p:nvPr/>
+        </p:nvSpPr>
+        <p:spPr>
+          <a:xfrm>
+            <a:off x="2651760" y="3291840"/>
+            <a:ext cx="1188720" cy="274320"/>
+          </a:xfrm>
+          <a:prstGeom prst="rect">
+            <a:avLst/>
+          </a:prstGeom>
+          <a:solidFill>
+            <a:srgbClr val="FFFFFF"/>
+          </a:solidFill>
+          <a:ln w="6350">
+            <a:solidFill>
+              <a:srgbClr val="959595"/>
+            </a:solidFill>
+          </a:ln>
+        </p:spPr>
+        <p:style>
+          <a:lnRef idx="1">
+            <a:schemeClr val="accent1"/>
+          </a:lnRef>
+          <a:fillRef idx="3">
+            <a:schemeClr val="accent1"/>
+          </a:fillRef>
+          <a:effectRef idx="2">
+            <a:schemeClr val="accent1"/>
+          </a:effectRef>
+          <a:fontRef idx="minor">
+            <a:schemeClr val="lt1"/>
+          </a:fontRef>
+        </p:style>
+        <p:txBody>
+          <a:bodyPr rtlCol="0" anchor="ctr"/>
+          <a:lstStyle/>
+          <a:p>
+            <a:pPr algn="ctr">
+              <a:defRPr sz="850"/>
+            </a:pPr>
+            <a:r>
+              <a:t>₹20.6 Cr</a:t>
+            </a:r>
+          </a:p>
+        </p:txBody>
+      </p:sp>
+      <p:sp>
+        <p:nvSpPr>
+          <p:cNvPr id="59" name="Rectangle 58"/>
+          <p:cNvSpPr/>
+          <p:nvPr/>
+        </p:nvSpPr>
+        <p:spPr>
+          <a:xfrm>
+            <a:off x="3840480" y="3291840"/>
+            <a:ext cx="1280160" cy="274320"/>
+          </a:xfrm>
+          <a:prstGeom prst="rect">
+            <a:avLst/>
+          </a:prstGeom>
+          <a:solidFill>
+            <a:srgbClr val="FFFFFF"/>
+          </a:solidFill>
+          <a:ln w="6350">
+            <a:solidFill>
+              <a:srgbClr val="959595"/>
+            </a:solidFill>
+          </a:ln>
+        </p:spPr>
+        <p:style>
+          <a:lnRef idx="1">
+            <a:schemeClr val="accent1"/>
+          </a:lnRef>
+          <a:fillRef idx="3">
+            <a:schemeClr val="accent1"/>
+          </a:fillRef>
+          <a:effectRef idx="2">
+            <a:schemeClr val="accent1"/>
+          </a:effectRef>
+          <a:fontRef idx="minor">
+            <a:schemeClr val="lt1"/>
+          </a:fontRef>
+        </p:style>
+        <p:txBody>
+          <a:bodyPr rtlCol="0" anchor="ctr"/>
+          <a:lstStyle/>
+          <a:p>
+            <a:pPr algn="ctr">
+              <a:defRPr sz="850"/>
+            </a:pPr>
+            <a:r>
+              <a:t>₹24.3 Cr</a:t>
+            </a:r>
+          </a:p>
+        </p:txBody>
+      </p:sp>
+      <p:sp>
+        <p:nvSpPr>
+          <p:cNvPr id="60" name="Rectangle 59"/>
+          <p:cNvSpPr/>
+          <p:nvPr/>
+        </p:nvSpPr>
+        <p:spPr>
+          <a:xfrm>
+            <a:off x="5120640" y="3291840"/>
+            <a:ext cx="1097280" cy="274320"/>
+          </a:xfrm>
+          <a:prstGeom prst="rect">
+            <a:avLst/>
+          </a:prstGeom>
+          <a:solidFill>
+            <a:srgbClr val="FFFFFF"/>
+          </a:solidFill>
+          <a:ln w="6350">
+            <a:solidFill>
+              <a:srgbClr val="959595"/>
+            </a:solidFill>
+          </a:ln>
+        </p:spPr>
+        <p:style>
+          <a:lnRef idx="1">
+            <a:schemeClr val="accent1"/>
+          </a:lnRef>
+          <a:fillRef idx="3">
+            <a:schemeClr val="accent1"/>
+          </a:fillRef>
+          <a:effectRef idx="2">
+            <a:schemeClr val="accent1"/>
+          </a:effectRef>
+          <a:fontRef idx="minor">
+            <a:schemeClr val="lt1"/>
+          </a:fontRef>
+        </p:style>
+        <p:txBody>
+          <a:bodyPr rtlCol="0" anchor="ctr"/>
+          <a:lstStyle/>
+          <a:p>
+            <a:pPr algn="ctr">
+              <a:defRPr sz="850" b="1">
+                <a:solidFill>
+                  <a:srgbClr val="2A9D8F"/>
+                </a:solidFill>
+              </a:defRPr>
+            </a:pPr>
+            <a:r>
+              <a:t>+18.0%</a:t>
+            </a:r>
+          </a:p>
+        </p:txBody>
+      </p:sp>
+      <p:sp>
+        <p:nvSpPr>
+          <p:cNvPr id="61" name="Rectangle 60"/>
+          <p:cNvSpPr/>
+          <p:nvPr/>
+        </p:nvSpPr>
+        <p:spPr>
+          <a:xfrm>
+            <a:off x="6217920" y="3291840"/>
+            <a:ext cx="1554480" cy="274320"/>
+          </a:xfrm>
+          <a:prstGeom prst="rect">
+            <a:avLst/>
+          </a:prstGeom>
+          <a:solidFill>
+            <a:srgbClr val="FFFFFF"/>
+          </a:solidFill>
+          <a:ln w="6350">
+            <a:solidFill>
+              <a:srgbClr val="959595"/>
+            </a:solidFill>
+          </a:ln>
+        </p:spPr>
+        <p:style>
+          <a:lnRef idx="1">
+            <a:schemeClr val="accent1"/>
+          </a:lnRef>
+          <a:fillRef idx="3">
+            <a:schemeClr val="accent1"/>
+          </a:fillRef>
+          <a:effectRef idx="2">
+            <a:schemeClr val="accent1"/>
+          </a:effectRef>
+          <a:fontRef idx="minor">
+            <a:schemeClr val="lt1"/>
+          </a:fontRef>
+        </p:style>
+        <p:txBody>
+          <a:bodyPr rtlCol="0" anchor="ctr"/>
+          <a:lstStyle/>
+          <a:p>
+            <a:pPr algn="ctr">
+              <a:defRPr sz="850"/>
+            </a:pPr>
+            <a:r>
+              <a:t>24-Aug</a:t>
+            </a:r>
+          </a:p>
+        </p:txBody>
+      </p:sp>
+      <p:sp>
+        <p:nvSpPr>
+          <p:cNvPr id="62" name="Rectangle 61"/>
+          <p:cNvSpPr/>
+          <p:nvPr/>
+        </p:nvSpPr>
+        <p:spPr>
+          <a:xfrm>
+            <a:off x="457200" y="3566160"/>
+            <a:ext cx="8229600" cy="274320"/>
+          </a:xfrm>
+          <a:prstGeom prst="rect">
+            <a:avLst/>
+          </a:prstGeom>
+          <a:solidFill>
+            <a:srgbClr val="F5F5F5"/>
+          </a:solidFill>
+          <a:ln/>
+        </p:spPr>
+        <p:style>
+          <a:lnRef idx="1">
+            <a:schemeClr val="accent1"/>
+          </a:lnRef>
+          <a:fillRef idx="3">
+            <a:schemeClr val="accent1"/>
+          </a:fillRef>
+          <a:effectRef idx="2">
+            <a:schemeClr val="accent1"/>
+          </a:effectRef>
+          <a:fontRef idx="minor">
+            <a:schemeClr val="lt1"/>
+          </a:fontRef>
+        </p:style>
+        <p:txBody>
+          <a:bodyPr rtlCol="0" anchor="ctr"/>
+          <a:lstStyle/>
+          <a:p>
+            <a:pPr algn="ctr"/>
+          </a:p>
+        </p:txBody>
+      </p:sp>
+      <p:sp>
+        <p:nvSpPr>
+          <p:cNvPr id="63" name="Rectangle 62"/>
+          <p:cNvSpPr/>
+          <p:nvPr/>
+        </p:nvSpPr>
+        <p:spPr>
+          <a:xfrm>
+            <a:off x="457200" y="3566160"/>
+            <a:ext cx="1005840" cy="274320"/>
+          </a:xfrm>
+          <a:prstGeom prst="rect">
+            <a:avLst/>
+          </a:prstGeom>
+          <a:solidFill>
+            <a:srgbClr val="FFFFFF"/>
+          </a:solidFill>
+          <a:ln w="6350">
+            <a:solidFill>
+              <a:srgbClr val="959595"/>
+            </a:solidFill>
+          </a:ln>
+        </p:spPr>
+        <p:style>
+          <a:lnRef idx="1">
+            <a:schemeClr val="accent1"/>
+          </a:lnRef>
+          <a:fillRef idx="3">
+            <a:schemeClr val="accent1"/>
+          </a:fillRef>
+          <a:effectRef idx="2">
+            <a:schemeClr val="accent1"/>
+          </a:effectRef>
+          <a:fontRef idx="minor">
+            <a:schemeClr val="lt1"/>
+          </a:fontRef>
+        </p:style>
+        <p:txBody>
+          <a:bodyPr rtlCol="0" anchor="ctr"/>
+          <a:lstStyle/>
+          <a:p>
+            <a:pPr algn="ctr">
+              <a:defRPr sz="850" b="1">
+                <a:solidFill>
+                  <a:srgbClr val="006EE6"/>
+                </a:solidFill>
+              </a:defRPr>
+            </a:pPr>
+            <a:r>
+              <a:t>NKAM</a:t>
+            </a:r>
+          </a:p>
+        </p:txBody>
+      </p:sp>
+      <p:sp>
+        <p:nvSpPr>
+          <p:cNvPr id="64" name="Rectangle 63"/>
+          <p:cNvSpPr/>
+          <p:nvPr/>
+        </p:nvSpPr>
+        <p:spPr>
+          <a:xfrm>
+            <a:off x="1463040" y="3566160"/>
+            <a:ext cx="1188720" cy="274320"/>
+          </a:xfrm>
+          <a:prstGeom prst="rect">
+            <a:avLst/>
+          </a:prstGeom>
+          <a:solidFill>
+            <a:srgbClr val="FFFFFF"/>
+          </a:solidFill>
+          <a:ln w="6350">
+            <a:solidFill>
+              <a:srgbClr val="959595"/>
+            </a:solidFill>
+          </a:ln>
+        </p:spPr>
+        <p:style>
+          <a:lnRef idx="1">
+            <a:schemeClr val="accent1"/>
+          </a:lnRef>
+          <a:fillRef idx="3">
+            <a:schemeClr val="accent1"/>
+          </a:fillRef>
+          <a:effectRef idx="2">
+            <a:schemeClr val="accent1"/>
+          </a:effectRef>
+          <a:fontRef idx="minor">
+            <a:schemeClr val="lt1"/>
+          </a:fontRef>
+        </p:style>
+        <p:txBody>
+          <a:bodyPr rtlCol="0" anchor="ctr"/>
+          <a:lstStyle/>
+          <a:p>
+            <a:pPr algn="l">
+              <a:defRPr sz="850"/>
+            </a:pPr>
+            <a:r>
+              <a:t>Walmart</a:t>
+            </a:r>
+          </a:p>
+        </p:txBody>
+      </p:sp>
+      <p:sp>
+        <p:nvSpPr>
+          <p:cNvPr id="65" name="Rectangle 64"/>
+          <p:cNvSpPr/>
+          <p:nvPr/>
+        </p:nvSpPr>
+        <p:spPr>
+          <a:xfrm>
+            <a:off x="2651760" y="3566160"/>
+            <a:ext cx="1188720" cy="274320"/>
+          </a:xfrm>
+          <a:prstGeom prst="rect">
+            <a:avLst/>
+          </a:prstGeom>
+          <a:solidFill>
+            <a:srgbClr val="FFFFFF"/>
+          </a:solidFill>
+          <a:ln w="6350">
+            <a:solidFill>
+              <a:srgbClr val="959595"/>
+            </a:solidFill>
+          </a:ln>
+        </p:spPr>
+        <p:style>
+          <a:lnRef idx="1">
+            <a:schemeClr val="accent1"/>
+          </a:lnRef>
+          <a:fillRef idx="3">
+            <a:schemeClr val="accent1"/>
+          </a:fillRef>
+          <a:effectRef idx="2">
+            <a:schemeClr val="accent1"/>
+          </a:effectRef>
+          <a:fontRef idx="minor">
+            <a:schemeClr val="lt1"/>
+          </a:fontRef>
+        </p:style>
+        <p:txBody>
+          <a:bodyPr rtlCol="0" anchor="ctr"/>
+          <a:lstStyle/>
+          <a:p>
+            <a:pPr algn="ctr">
+              <a:defRPr sz="850"/>
+            </a:pPr>
+            <a:r>
+              <a:t>₹10.6 Cr</a:t>
+            </a:r>
+          </a:p>
+        </p:txBody>
+      </p:sp>
+      <p:sp>
+        <p:nvSpPr>
+          <p:cNvPr id="66" name="Rectangle 65"/>
+          <p:cNvSpPr/>
+          <p:nvPr/>
+        </p:nvSpPr>
+        <p:spPr>
+          <a:xfrm>
+            <a:off x="3840480" y="3566160"/>
+            <a:ext cx="1280160" cy="274320"/>
+          </a:xfrm>
+          <a:prstGeom prst="rect">
+            <a:avLst/>
+          </a:prstGeom>
+          <a:solidFill>
+            <a:srgbClr val="FFFFFF"/>
+          </a:solidFill>
+          <a:ln w="6350">
+            <a:solidFill>
+              <a:srgbClr val="959595"/>
+            </a:solidFill>
+          </a:ln>
+        </p:spPr>
+        <p:style>
+          <a:lnRef idx="1">
+            <a:schemeClr val="accent1"/>
+          </a:lnRef>
+          <a:fillRef idx="3">
+            <a:schemeClr val="accent1"/>
+          </a:fillRef>
+          <a:effectRef idx="2">
+            <a:schemeClr val="accent1"/>
+          </a:effectRef>
+          <a:fontRef idx="minor">
+            <a:schemeClr val="lt1"/>
+          </a:fontRef>
+        </p:style>
+        <p:txBody>
+          <a:bodyPr rtlCol="0" anchor="ctr"/>
+          <a:lstStyle/>
+          <a:p>
+            <a:pPr algn="ctr">
+              <a:defRPr sz="850"/>
+            </a:pPr>
+            <a:r>
+              <a:t>₹12.1 Cr</a:t>
+            </a:r>
+          </a:p>
+        </p:txBody>
+      </p:sp>
+      <p:sp>
+        <p:nvSpPr>
+          <p:cNvPr id="67" name="Rectangle 66"/>
+          <p:cNvSpPr/>
+          <p:nvPr/>
+        </p:nvSpPr>
+        <p:spPr>
+          <a:xfrm>
+            <a:off x="5120640" y="3566160"/>
+            <a:ext cx="1097280" cy="274320"/>
+          </a:xfrm>
+          <a:prstGeom prst="rect">
+            <a:avLst/>
+          </a:prstGeom>
+          <a:solidFill>
+            <a:srgbClr val="FFFFFF"/>
+          </a:solidFill>
+          <a:ln w="6350">
+            <a:solidFill>
+              <a:srgbClr val="959595"/>
+            </a:solidFill>
+          </a:ln>
+        </p:spPr>
+        <p:style>
+          <a:lnRef idx="1">
+            <a:schemeClr val="accent1"/>
+          </a:lnRef>
+          <a:fillRef idx="3">
+            <a:schemeClr val="accent1"/>
+          </a:fillRef>
+          <a:effectRef idx="2">
+            <a:schemeClr val="accent1"/>
+          </a:effectRef>
+          <a:fontRef idx="minor">
+            <a:schemeClr val="lt1"/>
+          </a:fontRef>
+        </p:style>
+        <p:txBody>
+          <a:bodyPr rtlCol="0" anchor="ctr"/>
+          <a:lstStyle/>
+          <a:p>
+            <a:pPr algn="ctr">
+              <a:defRPr sz="850" b="1">
+                <a:solidFill>
+                  <a:srgbClr val="2A9D8F"/>
+                </a:solidFill>
+              </a:defRPr>
+            </a:pPr>
+            <a:r>
+              <a:t>+14.2%</a:t>
+            </a:r>
+          </a:p>
+        </p:txBody>
+      </p:sp>
+      <p:sp>
+        <p:nvSpPr>
+          <p:cNvPr id="68" name="Rectangle 67"/>
+          <p:cNvSpPr/>
+          <p:nvPr/>
+        </p:nvSpPr>
+        <p:spPr>
+          <a:xfrm>
+            <a:off x="6217920" y="3566160"/>
+            <a:ext cx="1554480" cy="274320"/>
+          </a:xfrm>
+          <a:prstGeom prst="rect">
+            <a:avLst/>
+          </a:prstGeom>
+          <a:solidFill>
+            <a:srgbClr val="FFFFFF"/>
+          </a:solidFill>
+          <a:ln w="6350">
+            <a:solidFill>
+              <a:srgbClr val="959595"/>
+            </a:solidFill>
+          </a:ln>
+        </p:spPr>
+        <p:style>
+          <a:lnRef idx="1">
+            <a:schemeClr val="accent1"/>
+          </a:lnRef>
+          <a:fillRef idx="3">
+            <a:schemeClr val="accent1"/>
+          </a:fillRef>
+          <a:effectRef idx="2">
+            <a:schemeClr val="accent1"/>
+          </a:effectRef>
+          <a:fontRef idx="minor">
+            <a:schemeClr val="lt1"/>
+          </a:fontRef>
+        </p:style>
+        <p:txBody>
+          <a:bodyPr rtlCol="0" anchor="ctr"/>
+          <a:lstStyle/>
+          <a:p>
+            <a:pPr algn="ctr">
+              <a:defRPr sz="850"/>
+            </a:pPr>
+            <a:r>
+              <a:t>21-Aug</a:t>
+            </a:r>
+          </a:p>
+        </p:txBody>
+      </p:sp>
+      <p:sp>
+        <p:nvSpPr>
+          <p:cNvPr id="69" name="TextBox 68"/>
+          <p:cNvSpPr txBox="1"/>
+          <p:nvPr/>
+        </p:nvSpPr>
+        <p:spPr>
+          <a:xfrm>
+            <a:off x="457200" y="6217920"/>
+            <a:ext cx="8229600" cy="548640"/>
+          </a:xfrm>
+          <a:prstGeom prst="rect">
+            <a:avLst/>
+          </a:prstGeom>
+          <a:noFill/>
+        </p:spPr>
+        <p:txBody>
+          <a:bodyPr wrap="square">
+            <a:spAutoFit/>
+          </a:bodyPr>
+          <a:lstStyle/>
+          <a:p>
+            <a:pPr>
+              <a:defRPr sz="1000" i="1">
+                <a:solidFill>
+                  <a:srgbClr val="959595"/>
+                </a:solidFill>
+              </a:defRPr>
+            </a:pPr>
+            <a:r>
+              <a:t>Jul Combined = ₹241.4 Cr | Aug Target = ₹260 Cr (+7.7% aggregate) | Weekly tracking: Mon 9am Ops Sync</a:t>
             </a:r>
           </a:p>
         </p:txBody>

</xml_diff>